<commit_message>
chore: update 2 examples
</commit_message>
<xml_diff>
--- a/seminar-ios-vku-ca1.pptx
+++ b/seminar-ios-vku-ca1.pptx
@@ -5,7 +5,7 @@
     <p:sldMasterId id="2147483648" r:id="rId1"/>
   </p:sldMasterIdLst>
   <p:notesMasterIdLst>
-    <p:notesMasterId r:id="rId31"/>
+    <p:notesMasterId r:id="rId34"/>
   </p:notesMasterIdLst>
   <p:sldIdLst>
     <p:sldId id="256" r:id="rId2"/>
@@ -14,29 +14,32 @@
     <p:sldId id="259" r:id="rId5"/>
     <p:sldId id="272" r:id="rId6"/>
     <p:sldId id="261" r:id="rId7"/>
-    <p:sldId id="262" r:id="rId8"/>
-    <p:sldId id="263" r:id="rId9"/>
-    <p:sldId id="264" r:id="rId10"/>
-    <p:sldId id="265" r:id="rId11"/>
-    <p:sldId id="266" r:id="rId12"/>
-    <p:sldId id="267" r:id="rId13"/>
-    <p:sldId id="268" r:id="rId14"/>
-    <p:sldId id="269" r:id="rId15"/>
-    <p:sldId id="270" r:id="rId16"/>
-    <p:sldId id="271" r:id="rId17"/>
-    <p:sldId id="273" r:id="rId18"/>
-    <p:sldId id="274" r:id="rId19"/>
-    <p:sldId id="275" r:id="rId20"/>
-    <p:sldId id="276" r:id="rId21"/>
-    <p:sldId id="277" r:id="rId22"/>
-    <p:sldId id="278" r:id="rId23"/>
-    <p:sldId id="279" r:id="rId24"/>
-    <p:sldId id="280" r:id="rId25"/>
-    <p:sldId id="281" r:id="rId26"/>
-    <p:sldId id="282" r:id="rId27"/>
-    <p:sldId id="284" r:id="rId28"/>
-    <p:sldId id="283" r:id="rId29"/>
-    <p:sldId id="285" r:id="rId30"/>
+    <p:sldId id="288" r:id="rId8"/>
+    <p:sldId id="262" r:id="rId9"/>
+    <p:sldId id="263" r:id="rId10"/>
+    <p:sldId id="264" r:id="rId11"/>
+    <p:sldId id="265" r:id="rId12"/>
+    <p:sldId id="266" r:id="rId13"/>
+    <p:sldId id="267" r:id="rId14"/>
+    <p:sldId id="268" r:id="rId15"/>
+    <p:sldId id="269" r:id="rId16"/>
+    <p:sldId id="270" r:id="rId17"/>
+    <p:sldId id="271" r:id="rId18"/>
+    <p:sldId id="273" r:id="rId19"/>
+    <p:sldId id="274" r:id="rId20"/>
+    <p:sldId id="275" r:id="rId21"/>
+    <p:sldId id="276" r:id="rId22"/>
+    <p:sldId id="277" r:id="rId23"/>
+    <p:sldId id="278" r:id="rId24"/>
+    <p:sldId id="279" r:id="rId25"/>
+    <p:sldId id="280" r:id="rId26"/>
+    <p:sldId id="281" r:id="rId27"/>
+    <p:sldId id="282" r:id="rId28"/>
+    <p:sldId id="284" r:id="rId29"/>
+    <p:sldId id="289" r:id="rId30"/>
+    <p:sldId id="283" r:id="rId31"/>
+    <p:sldId id="287" r:id="rId32"/>
+    <p:sldId id="285" r:id="rId33"/>
   </p:sldIdLst>
   <p:sldSz cx="12192000" cy="6858000"/>
   <p:notesSz cx="6858000" cy="12192000"/>
@@ -2034,7 +2037,13 @@
   <p:cSld>
     <p:spTree>
       <p:nvGrpSpPr>
-        <p:cNvPr id="1" name=""/>
+        <p:cNvPr id="1" name="">
+          <a:extLst>
+            <a:ext uri="{FF2B5EF4-FFF2-40B4-BE49-F238E27FC236}">
+              <a16:creationId xmlns:a16="http://schemas.microsoft.com/office/drawing/2014/main" id="{E5273814-034A-7DE0-DCD1-67FA452228DE}"/>
+            </a:ext>
+          </a:extLst>
+        </p:cNvPr>
         <p:cNvGrpSpPr/>
         <p:nvPr/>
       </p:nvGrpSpPr>
@@ -2048,7 +2057,13 @@
       </p:grpSpPr>
       <p:sp>
         <p:nvSpPr>
-          <p:cNvPr id="2" name="Slide Image Placeholder 1"/>
+          <p:cNvPr id="2" name="Slide Image Placeholder 1">
+            <a:extLst>
+              <a:ext uri="{FF2B5EF4-FFF2-40B4-BE49-F238E27FC236}">
+                <a16:creationId xmlns:a16="http://schemas.microsoft.com/office/drawing/2014/main" id="{7F564B37-8850-394D-1787-3A0A4D598769}"/>
+              </a:ext>
+            </a:extLst>
+          </p:cNvPr>
           <p:cNvSpPr>
             <a:spLocks noGrp="1" noRot="1" noChangeAspect="1"/>
           </p:cNvSpPr>
@@ -2060,7 +2075,13 @@
       </p:sp>
       <p:sp>
         <p:nvSpPr>
-          <p:cNvPr id="3" name="Notes Placeholder 2"/>
+          <p:cNvPr id="3" name="Notes Placeholder 2">
+            <a:extLst>
+              <a:ext uri="{FF2B5EF4-FFF2-40B4-BE49-F238E27FC236}">
+                <a16:creationId xmlns:a16="http://schemas.microsoft.com/office/drawing/2014/main" id="{4F3395A3-7FE0-A78C-70C8-6AED350CFD71}"/>
+              </a:ext>
+            </a:extLst>
+          </p:cNvPr>
           <p:cNvSpPr>
             <a:spLocks noGrp="1"/>
           </p:cNvSpPr>
@@ -2079,7 +2100,13 @@
       </p:sp>
       <p:sp>
         <p:nvSpPr>
-          <p:cNvPr id="4" name="Slide Number Placeholder 3"/>
+          <p:cNvPr id="4" name="Slide Number Placeholder 3">
+            <a:extLst>
+              <a:ext uri="{FF2B5EF4-FFF2-40B4-BE49-F238E27FC236}">
+                <a16:creationId xmlns:a16="http://schemas.microsoft.com/office/drawing/2014/main" id="{8364C96B-BB43-6FE8-AC82-BCA182029246}"/>
+              </a:ext>
+            </a:extLst>
+          </p:cNvPr>
           <p:cNvSpPr>
             <a:spLocks noGrp="1"/>
           </p:cNvSpPr>
@@ -2103,7 +2130,7 @@
     </p:spTree>
     <p:extLst>
       <p:ext uri="{BB962C8B-B14F-4D97-AF65-F5344CB8AC3E}">
-        <p14:creationId xmlns:p14="http://schemas.microsoft.com/office/powerpoint/2010/main" val="1024086991"/>
+        <p14:creationId xmlns:p14="http://schemas.microsoft.com/office/powerpoint/2010/main" val="844834379"/>
       </p:ext>
     </p:extLst>
   </p:cSld>
@@ -2179,6 +2206,174 @@
             <a:fld id="{F7021451-1387-4CA6-816F-3879F97B5CBC}" type="slidenum">
               <a:rPr lang="en-US"/>
               <a:t>3</a:t>
+            </a:fld>
+            <a:endParaRPr lang="en-US"/>
+          </a:p>
+        </p:txBody>
+      </p:sp>
+    </p:spTree>
+    <p:extLst>
+      <p:ext uri="{BB962C8B-B14F-4D97-AF65-F5344CB8AC3E}">
+        <p14:creationId xmlns:p14="http://schemas.microsoft.com/office/powerpoint/2010/main" val="1024086991"/>
+      </p:ext>
+    </p:extLst>
+  </p:cSld>
+  <p:clrMapOvr>
+    <a:masterClrMapping/>
+  </p:clrMapOvr>
+</p:notes>
+</file>
+
+<file path=ppt/notesSlides/notesSlide30.xml><?xml version="1.0" encoding="utf-8"?>
+<p:notes xmlns:a="http://schemas.openxmlformats.org/drawingml/2006/main" xmlns:r="http://schemas.openxmlformats.org/officeDocument/2006/relationships" xmlns:p="http://schemas.openxmlformats.org/presentationml/2006/main">
+  <p:cSld>
+    <p:spTree>
+      <p:nvGrpSpPr>
+        <p:cNvPr id="1" name=""/>
+        <p:cNvGrpSpPr/>
+        <p:nvPr/>
+      </p:nvGrpSpPr>
+      <p:grpSpPr>
+        <a:xfrm>
+          <a:off x="0" y="0"/>
+          <a:ext cx="0" cy="0"/>
+          <a:chOff x="0" y="0"/>
+          <a:chExt cx="0" cy="0"/>
+        </a:xfrm>
+      </p:grpSpPr>
+      <p:sp>
+        <p:nvSpPr>
+          <p:cNvPr id="2" name="Slide Image Placeholder 1"/>
+          <p:cNvSpPr>
+            <a:spLocks noGrp="1" noRot="1" noChangeAspect="1"/>
+          </p:cNvSpPr>
+          <p:nvPr>
+            <p:ph type="sldImg"/>
+          </p:nvPr>
+        </p:nvSpPr>
+        <p:spPr/>
+      </p:sp>
+      <p:sp>
+        <p:nvSpPr>
+          <p:cNvPr id="3" name="Notes Placeholder 2"/>
+          <p:cNvSpPr>
+            <a:spLocks noGrp="1"/>
+          </p:cNvSpPr>
+          <p:nvPr>
+            <p:ph type="body" idx="1"/>
+          </p:nvPr>
+        </p:nvSpPr>
+        <p:spPr/>
+        <p:txBody>
+          <a:bodyPr/>
+          <a:lstStyle/>
+          <a:p>
+            <a:endParaRPr lang="en-US" dirty="0"/>
+          </a:p>
+        </p:txBody>
+      </p:sp>
+      <p:sp>
+        <p:nvSpPr>
+          <p:cNvPr id="4" name="Slide Number Placeholder 3"/>
+          <p:cNvSpPr>
+            <a:spLocks noGrp="1"/>
+          </p:cNvSpPr>
+          <p:nvPr>
+            <p:ph type="sldNum" sz="quarter" idx="10"/>
+          </p:nvPr>
+        </p:nvSpPr>
+        <p:spPr/>
+        <p:txBody>
+          <a:bodyPr/>
+          <a:lstStyle/>
+          <a:p>
+            <a:fld id="{F7021451-1387-4CA6-816F-3879F97B5CBC}" type="slidenum">
+              <a:rPr lang="en-US"/>
+              <a:t>30</a:t>
+            </a:fld>
+            <a:endParaRPr lang="en-US"/>
+          </a:p>
+        </p:txBody>
+      </p:sp>
+    </p:spTree>
+    <p:extLst>
+      <p:ext uri="{BB962C8B-B14F-4D97-AF65-F5344CB8AC3E}">
+        <p14:creationId xmlns:p14="http://schemas.microsoft.com/office/powerpoint/2010/main" val="1024086991"/>
+      </p:ext>
+    </p:extLst>
+  </p:cSld>
+  <p:clrMapOvr>
+    <a:masterClrMapping/>
+  </p:clrMapOvr>
+</p:notes>
+</file>
+
+<file path=ppt/notesSlides/notesSlide31.xml><?xml version="1.0" encoding="utf-8"?>
+<p:notes xmlns:a="http://schemas.openxmlformats.org/drawingml/2006/main" xmlns:r="http://schemas.openxmlformats.org/officeDocument/2006/relationships" xmlns:p="http://schemas.openxmlformats.org/presentationml/2006/main">
+  <p:cSld>
+    <p:spTree>
+      <p:nvGrpSpPr>
+        <p:cNvPr id="1" name=""/>
+        <p:cNvGrpSpPr/>
+        <p:nvPr/>
+      </p:nvGrpSpPr>
+      <p:grpSpPr>
+        <a:xfrm>
+          <a:off x="0" y="0"/>
+          <a:ext cx="0" cy="0"/>
+          <a:chOff x="0" y="0"/>
+          <a:chExt cx="0" cy="0"/>
+        </a:xfrm>
+      </p:grpSpPr>
+      <p:sp>
+        <p:nvSpPr>
+          <p:cNvPr id="2" name="Slide Image Placeholder 1"/>
+          <p:cNvSpPr>
+            <a:spLocks noGrp="1" noRot="1" noChangeAspect="1"/>
+          </p:cNvSpPr>
+          <p:nvPr>
+            <p:ph type="sldImg"/>
+          </p:nvPr>
+        </p:nvSpPr>
+        <p:spPr/>
+      </p:sp>
+      <p:sp>
+        <p:nvSpPr>
+          <p:cNvPr id="3" name="Notes Placeholder 2"/>
+          <p:cNvSpPr>
+            <a:spLocks noGrp="1"/>
+          </p:cNvSpPr>
+          <p:nvPr>
+            <p:ph type="body" idx="1"/>
+          </p:nvPr>
+        </p:nvSpPr>
+        <p:spPr/>
+        <p:txBody>
+          <a:bodyPr/>
+          <a:lstStyle/>
+          <a:p>
+            <a:endParaRPr lang="en-US" dirty="0"/>
+          </a:p>
+        </p:txBody>
+      </p:sp>
+      <p:sp>
+        <p:nvSpPr>
+          <p:cNvPr id="4" name="Slide Number Placeholder 3"/>
+          <p:cNvSpPr>
+            <a:spLocks noGrp="1"/>
+          </p:cNvSpPr>
+          <p:nvPr>
+            <p:ph type="sldNum" sz="quarter" idx="10"/>
+          </p:nvPr>
+        </p:nvSpPr>
+        <p:spPr/>
+        <p:txBody>
+          <a:bodyPr/>
+          <a:lstStyle/>
+          <a:p>
+            <a:fld id="{F7021451-1387-4CA6-816F-3879F97B5CBC}" type="slidenum">
+              <a:rPr lang="en-US"/>
+              <a:t>32</a:t>
             </a:fld>
             <a:endParaRPr lang="en-US"/>
           </a:p>
@@ -2454,7 +2649,13 @@
   <p:cSld>
     <p:spTree>
       <p:nvGrpSpPr>
-        <p:cNvPr id="1" name=""/>
+        <p:cNvPr id="1" name="">
+          <a:extLst>
+            <a:ext uri="{FF2B5EF4-FFF2-40B4-BE49-F238E27FC236}">
+              <a16:creationId xmlns:a16="http://schemas.microsoft.com/office/drawing/2014/main" id="{8D4C8D5F-1EE0-F070-3D1D-5CB79F23FBE0}"/>
+            </a:ext>
+          </a:extLst>
+        </p:cNvPr>
         <p:cNvGrpSpPr/>
         <p:nvPr/>
       </p:nvGrpSpPr>
@@ -2468,7 +2669,13 @@
       </p:grpSpPr>
       <p:sp>
         <p:nvSpPr>
-          <p:cNvPr id="2" name="Slide Image Placeholder 1"/>
+          <p:cNvPr id="2" name="Slide Image Placeholder 1">
+            <a:extLst>
+              <a:ext uri="{FF2B5EF4-FFF2-40B4-BE49-F238E27FC236}">
+                <a16:creationId xmlns:a16="http://schemas.microsoft.com/office/drawing/2014/main" id="{89DBADBD-AA51-F331-36C1-C2D881C49F4B}"/>
+              </a:ext>
+            </a:extLst>
+          </p:cNvPr>
           <p:cNvSpPr>
             <a:spLocks noGrp="1" noRot="1" noChangeAspect="1"/>
           </p:cNvSpPr>
@@ -2480,7 +2687,13 @@
       </p:sp>
       <p:sp>
         <p:nvSpPr>
-          <p:cNvPr id="3" name="Notes Placeholder 2"/>
+          <p:cNvPr id="3" name="Notes Placeholder 2">
+            <a:extLst>
+              <a:ext uri="{FF2B5EF4-FFF2-40B4-BE49-F238E27FC236}">
+                <a16:creationId xmlns:a16="http://schemas.microsoft.com/office/drawing/2014/main" id="{58591D5E-F7AF-0F42-3ADE-62FCC09BAF44}"/>
+              </a:ext>
+            </a:extLst>
+          </p:cNvPr>
           <p:cNvSpPr>
             <a:spLocks noGrp="1"/>
           </p:cNvSpPr>
@@ -2499,7 +2712,13 @@
       </p:sp>
       <p:sp>
         <p:nvSpPr>
-          <p:cNvPr id="4" name="Slide Number Placeholder 3"/>
+          <p:cNvPr id="4" name="Slide Number Placeholder 3">
+            <a:extLst>
+              <a:ext uri="{FF2B5EF4-FFF2-40B4-BE49-F238E27FC236}">
+                <a16:creationId xmlns:a16="http://schemas.microsoft.com/office/drawing/2014/main" id="{599239FD-28E8-523E-121A-5AFE13B6A40F}"/>
+              </a:ext>
+            </a:extLst>
+          </p:cNvPr>
           <p:cNvSpPr>
             <a:spLocks noGrp="1"/>
           </p:cNvSpPr>
@@ -2523,7 +2742,7 @@
     </p:spTree>
     <p:extLst>
       <p:ext uri="{BB962C8B-B14F-4D97-AF65-F5344CB8AC3E}">
-        <p14:creationId xmlns:p14="http://schemas.microsoft.com/office/powerpoint/2010/main" val="1024086991"/>
+        <p14:creationId xmlns:p14="http://schemas.microsoft.com/office/powerpoint/2010/main" val="3347228145"/>
       </p:ext>
     </p:extLst>
   </p:cSld>
@@ -3577,6 +3796,223 @@
 
 <file path=ppt/slides/slide10.xml><?xml version="1.0" encoding="utf-8"?>
 <p:sld xmlns:a="http://schemas.openxmlformats.org/drawingml/2006/main" xmlns:r="http://schemas.openxmlformats.org/officeDocument/2006/relationships" xmlns:p="http://schemas.openxmlformats.org/presentationml/2006/main">
+  <p:cSld name="Slide 9">
+    <p:bg>
+      <p:bgPr>
+        <a:solidFill>
+          <a:srgbClr val="1B3A1F"/>
+        </a:solidFill>
+        <a:effectLst/>
+      </p:bgPr>
+    </p:bg>
+    <p:spTree>
+      <p:nvGrpSpPr>
+        <p:cNvPr id="1" name=""/>
+        <p:cNvGrpSpPr/>
+        <p:nvPr/>
+      </p:nvGrpSpPr>
+      <p:grpSpPr>
+        <a:xfrm>
+          <a:off x="0" y="0"/>
+          <a:ext cx="0" cy="0"/>
+          <a:chOff x="0" y="0"/>
+          <a:chExt cx="0" cy="0"/>
+        </a:xfrm>
+      </p:grpSpPr>
+      <p:sp>
+        <p:nvSpPr>
+          <p:cNvPr id="2" name="Shape 0"/>
+          <p:cNvSpPr/>
+          <p:nvPr/>
+        </p:nvSpPr>
+        <p:spPr>
+          <a:xfrm>
+            <a:off x="0" y="0"/>
+            <a:ext cx="164592" cy="6858000"/>
+          </a:xfrm>
+          <a:prstGeom prst="rect">
+            <a:avLst/>
+          </a:prstGeom>
+          <a:solidFill>
+            <a:srgbClr val="97BC62"/>
+          </a:solidFill>
+          <a:ln w="12700">
+            <a:solidFill>
+              <a:srgbClr val="97BC62"/>
+            </a:solidFill>
+            <a:prstDash val="solid"/>
+          </a:ln>
+        </p:spPr>
+      </p:sp>
+      <p:sp>
+        <p:nvSpPr>
+          <p:cNvPr id="3" name="Shape 1"/>
+          <p:cNvSpPr/>
+          <p:nvPr/>
+        </p:nvSpPr>
+        <p:spPr>
+          <a:xfrm>
+            <a:off x="11521440" y="0"/>
+            <a:ext cx="640080" cy="164592"/>
+          </a:xfrm>
+          <a:prstGeom prst="rect">
+            <a:avLst/>
+          </a:prstGeom>
+          <a:solidFill>
+            <a:srgbClr val="97BC62"/>
+          </a:solidFill>
+          <a:ln w="12700">
+            <a:solidFill>
+              <a:srgbClr val="97BC62"/>
+            </a:solidFill>
+            <a:prstDash val="solid"/>
+          </a:ln>
+        </p:spPr>
+      </p:sp>
+      <p:sp>
+        <p:nvSpPr>
+          <p:cNvPr id="4" name="Text 2"/>
+          <p:cNvSpPr/>
+          <p:nvPr/>
+        </p:nvSpPr>
+        <p:spPr>
+          <a:xfrm>
+            <a:off x="731520" y="2377440"/>
+            <a:ext cx="10972800" cy="457200"/>
+          </a:xfrm>
+          <a:prstGeom prst="rect">
+            <a:avLst/>
+          </a:prstGeom>
+          <a:noFill/>
+          <a:ln/>
+        </p:spPr>
+        <p:txBody>
+          <a:bodyPr wrap="square" rtlCol="0" anchor="ctr"/>
+          <a:lstStyle/>
+          <a:p>
+            <a:pPr marL="0" indent="0">
+              <a:buNone/>
+            </a:pPr>
+            <a:r>
+              <a:rPr lang="en-US" sz="1800" b="1" kern="0" spc="400" dirty="0">
+                <a:solidFill>
+                  <a:srgbClr val="97BC62"/>
+                </a:solidFill>
+                <a:latin typeface="Helvetica" pitchFamily="34" charset="0"/>
+                <a:ea typeface="Helvetica" pitchFamily="34" charset="-122"/>
+                <a:cs typeface="Helvetica" pitchFamily="34" charset="-120"/>
+              </a:rPr>
+              <a:t>LỊCH SỬ NGÔN NGỮ</a:t>
+            </a:r>
+            <a:endParaRPr lang="en-US" sz="1800" dirty="0"/>
+          </a:p>
+        </p:txBody>
+      </p:sp>
+      <p:sp>
+        <p:nvSpPr>
+          <p:cNvPr id="5" name="Text 3"/>
+          <p:cNvSpPr/>
+          <p:nvPr/>
+        </p:nvSpPr>
+        <p:spPr>
+          <a:xfrm>
+            <a:off x="731520" y="2834640"/>
+            <a:ext cx="10972800" cy="1828800"/>
+          </a:xfrm>
+          <a:prstGeom prst="rect">
+            <a:avLst/>
+          </a:prstGeom>
+          <a:noFill/>
+          <a:ln/>
+        </p:spPr>
+        <p:txBody>
+          <a:bodyPr wrap="square" rtlCol="0" anchor="ctr"/>
+          <a:lstStyle/>
+          <a:p>
+            <a:pPr marL="0" indent="0">
+              <a:buNone/>
+            </a:pPr>
+            <a:r>
+              <a:rPr lang="en-US" sz="5200" b="1" dirty="0">
+                <a:solidFill>
+                  <a:srgbClr val="FFFFFF"/>
+                </a:solidFill>
+                <a:latin typeface="Helvetica" pitchFamily="34" charset="0"/>
+                <a:ea typeface="Helvetica" pitchFamily="34" charset="-122"/>
+                <a:cs typeface="Helvetica" pitchFamily="34" charset="-120"/>
+              </a:rPr>
+              <a:t>Từ Objective-C</a:t>
+            </a:r>
+            <a:endParaRPr lang="en-US" sz="5200" dirty="0"/>
+          </a:p>
+          <a:p>
+            <a:pPr marL="0" indent="0">
+              <a:buNone/>
+            </a:pPr>
+            <a:r>
+              <a:rPr lang="en-US" sz="5200" b="1" dirty="0">
+                <a:solidFill>
+                  <a:srgbClr val="FFFFFF"/>
+                </a:solidFill>
+                <a:latin typeface="Helvetica" pitchFamily="34" charset="0"/>
+                <a:ea typeface="Helvetica" pitchFamily="34" charset="-122"/>
+                <a:cs typeface="Helvetica" pitchFamily="34" charset="-120"/>
+              </a:rPr>
+              <a:t>đến Swift</a:t>
+            </a:r>
+            <a:endParaRPr lang="en-US" sz="5200" dirty="0"/>
+          </a:p>
+        </p:txBody>
+      </p:sp>
+      <p:sp>
+        <p:nvSpPr>
+          <p:cNvPr id="6" name="Text 4"/>
+          <p:cNvSpPr/>
+          <p:nvPr/>
+        </p:nvSpPr>
+        <p:spPr>
+          <a:xfrm>
+            <a:off x="7772400" y="6492240"/>
+            <a:ext cx="4114800" cy="274320"/>
+          </a:xfrm>
+          <a:prstGeom prst="rect">
+            <a:avLst/>
+          </a:prstGeom>
+          <a:noFill/>
+          <a:ln/>
+        </p:spPr>
+        <p:txBody>
+          <a:bodyPr wrap="square" rtlCol="0" anchor="ctr"/>
+          <a:lstStyle/>
+          <a:p>
+            <a:pPr marL="0" indent="0" algn="r">
+              <a:buNone/>
+            </a:pPr>
+            <a:r>
+              <a:rPr lang="en-US" sz="1100" dirty="0">
+                <a:solidFill>
+                  <a:srgbClr val="97BC62"/>
+                </a:solidFill>
+                <a:latin typeface="Helvetica" pitchFamily="34" charset="0"/>
+                <a:ea typeface="Helvetica" pitchFamily="34" charset="-122"/>
+                <a:cs typeface="Helvetica" pitchFamily="34" charset="-120"/>
+              </a:rPr>
+              <a:t>Nguyễn Quế Lân · VNGalaxy</a:t>
+            </a:r>
+            <a:endParaRPr lang="en-US" sz="1100" dirty="0"/>
+          </a:p>
+        </p:txBody>
+      </p:sp>
+    </p:spTree>
+  </p:cSld>
+  <p:clrMapOvr>
+    <a:masterClrMapping/>
+  </p:clrMapOvr>
+</p:sld>
+</file>
+
+<file path=ppt/slides/slide11.xml><?xml version="1.0" encoding="utf-8"?>
+<p:sld xmlns:a="http://schemas.openxmlformats.org/drawingml/2006/main" xmlns:r="http://schemas.openxmlformats.org/officeDocument/2006/relationships" xmlns:p="http://schemas.openxmlformats.org/presentationml/2006/main">
   <p:cSld name="Slide 10">
     <p:bg>
       <p:bgPr>
@@ -4758,7 +5194,7 @@
 </p:sld>
 </file>
 
-<file path=ppt/slides/slide11.xml><?xml version="1.0" encoding="utf-8"?>
+<file path=ppt/slides/slide12.xml><?xml version="1.0" encoding="utf-8"?>
 <p:sld xmlns:a="http://schemas.openxmlformats.org/drawingml/2006/main" xmlns:r="http://schemas.openxmlformats.org/officeDocument/2006/relationships" xmlns:p="http://schemas.openxmlformats.org/presentationml/2006/main">
   <p:cSld name="Slide 11">
     <p:bg>
@@ -4975,7 +5411,7 @@
 </p:sld>
 </file>
 
-<file path=ppt/slides/slide12.xml><?xml version="1.0" encoding="utf-8"?>
+<file path=ppt/slides/slide13.xml><?xml version="1.0" encoding="utf-8"?>
 <p:sld xmlns:a="http://schemas.openxmlformats.org/drawingml/2006/main" xmlns:r="http://schemas.openxmlformats.org/officeDocument/2006/relationships" xmlns:p="http://schemas.openxmlformats.org/presentationml/2006/main">
   <p:cSld name="Slide 12">
     <p:bg>
@@ -5825,7 +6261,7 @@
 </p:sld>
 </file>
 
-<file path=ppt/slides/slide13.xml><?xml version="1.0" encoding="utf-8"?>
+<file path=ppt/slides/slide14.xml><?xml version="1.0" encoding="utf-8"?>
 <p:sld xmlns:a="http://schemas.openxmlformats.org/drawingml/2006/main" xmlns:r="http://schemas.openxmlformats.org/officeDocument/2006/relationships" xmlns:p="http://schemas.openxmlformats.org/presentationml/2006/main">
   <p:cSld name="Slide 13">
     <p:bg>
@@ -6672,7 +7108,7 @@
 </p:sld>
 </file>
 
-<file path=ppt/slides/slide14.xml><?xml version="1.0" encoding="utf-8"?>
+<file path=ppt/slides/slide15.xml><?xml version="1.0" encoding="utf-8"?>
 <p:sld xmlns:a="http://schemas.openxmlformats.org/drawingml/2006/main" xmlns:r="http://schemas.openxmlformats.org/officeDocument/2006/relationships" xmlns:p="http://schemas.openxmlformats.org/presentationml/2006/main">
   <p:cSld name="Slide 14">
     <p:bg>
@@ -6889,7 +7325,7 @@
 </p:sld>
 </file>
 
-<file path=ppt/slides/slide15.xml><?xml version="1.0" encoding="utf-8"?>
+<file path=ppt/slides/slide16.xml><?xml version="1.0" encoding="utf-8"?>
 <p:sld xmlns:a="http://schemas.openxmlformats.org/drawingml/2006/main" xmlns:r="http://schemas.openxmlformats.org/officeDocument/2006/relationships" xmlns:p="http://schemas.openxmlformats.org/presentationml/2006/main">
   <p:cSld name="Slide 15">
     <p:bg>
@@ -7723,7 +8159,7 @@
 </p:sld>
 </file>
 
-<file path=ppt/slides/slide16.xml><?xml version="1.0" encoding="utf-8"?>
+<file path=ppt/slides/slide17.xml><?xml version="1.0" encoding="utf-8"?>
 <p:sld xmlns:a="http://schemas.openxmlformats.org/drawingml/2006/main" xmlns:r="http://schemas.openxmlformats.org/officeDocument/2006/relationships" xmlns:p="http://schemas.openxmlformats.org/presentationml/2006/main">
   <p:cSld name="Slide 16">
     <p:bg>
@@ -8708,7 +9144,7 @@
 </p:sld>
 </file>
 
-<file path=ppt/slides/slide17.xml><?xml version="1.0" encoding="utf-8"?>
+<file path=ppt/slides/slide18.xml><?xml version="1.0" encoding="utf-8"?>
 <p:sld xmlns:a="http://schemas.openxmlformats.org/drawingml/2006/main" xmlns:r="http://schemas.openxmlformats.org/officeDocument/2006/relationships" xmlns:p="http://schemas.openxmlformats.org/presentationml/2006/main">
   <p:cSld name="Slide 18">
     <p:bg>
@@ -8958,7 +9394,7 @@
 </p:sld>
 </file>
 
-<file path=ppt/slides/slide18.xml><?xml version="1.0" encoding="utf-8"?>
+<file path=ppt/slides/slide19.xml><?xml version="1.0" encoding="utf-8"?>
 <p:sld xmlns:a="http://schemas.openxmlformats.org/drawingml/2006/main" xmlns:r="http://schemas.openxmlformats.org/officeDocument/2006/relationships" xmlns:p="http://schemas.openxmlformats.org/presentationml/2006/main">
   <p:cSld name="Slide 19">
     <p:bg>
@@ -9560,574 +9996,6 @@
       <p:sp>
         <p:nvSpPr>
           <p:cNvPr id="19" name="Text 17"/>
-          <p:cNvSpPr/>
-          <p:nvPr/>
-        </p:nvSpPr>
-        <p:spPr>
-          <a:xfrm>
-            <a:off x="7772400" y="6492240"/>
-            <a:ext cx="4114800" cy="274320"/>
-          </a:xfrm>
-          <a:prstGeom prst="rect">
-            <a:avLst/>
-          </a:prstGeom>
-          <a:noFill/>
-          <a:ln/>
-        </p:spPr>
-        <p:txBody>
-          <a:bodyPr wrap="square" rtlCol="0" anchor="ctr"/>
-          <a:lstStyle/>
-          <a:p>
-            <a:pPr marL="0" indent="0" algn="r">
-              <a:buNone/>
-            </a:pPr>
-            <a:r>
-              <a:rPr lang="en-US" sz="1100" dirty="0">
-                <a:solidFill>
-                  <a:srgbClr val="555555"/>
-                </a:solidFill>
-                <a:latin typeface="Helvetica" pitchFamily="34" charset="0"/>
-                <a:ea typeface="Helvetica" pitchFamily="34" charset="-122"/>
-                <a:cs typeface="Helvetica" pitchFamily="34" charset="-120"/>
-              </a:rPr>
-              <a:t>Nguyễn Quế Lân · VNGalaxy</a:t>
-            </a:r>
-            <a:endParaRPr lang="en-US" sz="1100" dirty="0"/>
-          </a:p>
-        </p:txBody>
-      </p:sp>
-    </p:spTree>
-  </p:cSld>
-  <p:clrMapOvr>
-    <a:masterClrMapping/>
-  </p:clrMapOvr>
-</p:sld>
-</file>
-
-<file path=ppt/slides/slide19.xml><?xml version="1.0" encoding="utf-8"?>
-<p:sld xmlns:a="http://schemas.openxmlformats.org/drawingml/2006/main" xmlns:r="http://schemas.openxmlformats.org/officeDocument/2006/relationships" xmlns:p="http://schemas.openxmlformats.org/presentationml/2006/main">
-  <p:cSld name="Slide 20">
-    <p:bg>
-      <p:bgPr>
-        <a:solidFill>
-          <a:srgbClr val="F7FBF6"/>
-        </a:solidFill>
-        <a:effectLst/>
-      </p:bgPr>
-    </p:bg>
-    <p:spTree>
-      <p:nvGrpSpPr>
-        <p:cNvPr id="1" name=""/>
-        <p:cNvGrpSpPr/>
-        <p:nvPr/>
-      </p:nvGrpSpPr>
-      <p:grpSpPr>
-        <a:xfrm>
-          <a:off x="0" y="0"/>
-          <a:ext cx="0" cy="0"/>
-          <a:chOff x="0" y="0"/>
-          <a:chExt cx="0" cy="0"/>
-        </a:xfrm>
-      </p:grpSpPr>
-      <p:sp>
-        <p:nvSpPr>
-          <p:cNvPr id="2" name="Shape 0"/>
-          <p:cNvSpPr/>
-          <p:nvPr/>
-        </p:nvSpPr>
-        <p:spPr>
-          <a:xfrm>
-            <a:off x="0" y="0"/>
-            <a:ext cx="164592" cy="6858000"/>
-          </a:xfrm>
-          <a:prstGeom prst="rect">
-            <a:avLst/>
-          </a:prstGeom>
-          <a:solidFill>
-            <a:srgbClr val="2E7D32"/>
-          </a:solidFill>
-          <a:ln w="12700">
-            <a:solidFill>
-              <a:srgbClr val="2E7D32"/>
-            </a:solidFill>
-            <a:prstDash val="solid"/>
-          </a:ln>
-        </p:spPr>
-      </p:sp>
-      <p:sp>
-        <p:nvSpPr>
-          <p:cNvPr id="3" name="Shape 1"/>
-          <p:cNvSpPr/>
-          <p:nvPr/>
-        </p:nvSpPr>
-        <p:spPr>
-          <a:xfrm>
-            <a:off x="11521440" y="0"/>
-            <a:ext cx="640080" cy="164592"/>
-          </a:xfrm>
-          <a:prstGeom prst="rect">
-            <a:avLst/>
-          </a:prstGeom>
-          <a:solidFill>
-            <a:srgbClr val="2E7D32"/>
-          </a:solidFill>
-          <a:ln w="12700">
-            <a:solidFill>
-              <a:srgbClr val="2E7D32"/>
-            </a:solidFill>
-            <a:prstDash val="solid"/>
-          </a:ln>
-        </p:spPr>
-      </p:sp>
-      <p:sp>
-        <p:nvSpPr>
-          <p:cNvPr id="4" name="Text 2"/>
-          <p:cNvSpPr/>
-          <p:nvPr/>
-        </p:nvSpPr>
-        <p:spPr>
-          <a:xfrm>
-            <a:off x="457200" y="320040"/>
-            <a:ext cx="11430000" cy="731520"/>
-          </a:xfrm>
-          <a:prstGeom prst="rect">
-            <a:avLst/>
-          </a:prstGeom>
-          <a:noFill/>
-          <a:ln/>
-        </p:spPr>
-        <p:txBody>
-          <a:bodyPr wrap="square" rtlCol="0" anchor="ctr"/>
-          <a:lstStyle/>
-          <a:p>
-            <a:pPr marL="0" indent="0">
-              <a:buNone/>
-            </a:pPr>
-            <a:r>
-              <a:rPr lang="en-US" sz="3200" b="1" dirty="0">
-                <a:solidFill>
-                  <a:srgbClr val="1B5E20"/>
-                </a:solidFill>
-                <a:latin typeface="Helvetica" pitchFamily="34" charset="0"/>
-                <a:ea typeface="Helvetica" pitchFamily="34" charset="-122"/>
-                <a:cs typeface="Helvetica" pitchFamily="34" charset="-120"/>
-              </a:rPr>
-              <a:t>Outsource ≠ Product</a:t>
-            </a:r>
-            <a:endParaRPr lang="en-US" sz="3200" dirty="0"/>
-          </a:p>
-        </p:txBody>
-      </p:sp>
-      <p:sp>
-        <p:nvSpPr>
-          <p:cNvPr id="5" name="Shape 3"/>
-          <p:cNvSpPr/>
-          <p:nvPr/>
-        </p:nvSpPr>
-        <p:spPr>
-          <a:xfrm>
-            <a:off x="457200" y="1005840"/>
-            <a:ext cx="1371600" cy="54864"/>
-          </a:xfrm>
-          <a:prstGeom prst="rect">
-            <a:avLst/>
-          </a:prstGeom>
-          <a:solidFill>
-            <a:srgbClr val="2E7D32"/>
-          </a:solidFill>
-          <a:ln w="12700">
-            <a:solidFill>
-              <a:srgbClr val="2E7D32"/>
-            </a:solidFill>
-            <a:prstDash val="solid"/>
-          </a:ln>
-        </p:spPr>
-      </p:sp>
-      <p:sp>
-        <p:nvSpPr>
-          <p:cNvPr id="6" name="Shape 4"/>
-          <p:cNvSpPr/>
-          <p:nvPr/>
-        </p:nvSpPr>
-        <p:spPr>
-          <a:xfrm>
-            <a:off x="457200" y="1280160"/>
-            <a:ext cx="5577840" cy="4937760"/>
-          </a:xfrm>
-          <a:prstGeom prst="rect">
-            <a:avLst/>
-          </a:prstGeom>
-          <a:solidFill>
-            <a:srgbClr val="FFFFFF"/>
-          </a:solidFill>
-          <a:ln w="12700">
-            <a:solidFill>
-              <a:srgbClr val="97BC62"/>
-            </a:solidFill>
-            <a:prstDash val="solid"/>
-          </a:ln>
-        </p:spPr>
-      </p:sp>
-      <p:sp>
-        <p:nvSpPr>
-          <p:cNvPr id="7" name="Text 5"/>
-          <p:cNvSpPr/>
-          <p:nvPr/>
-        </p:nvSpPr>
-        <p:spPr>
-          <a:xfrm>
-            <a:off x="640080" y="1417320"/>
-            <a:ext cx="5303520" cy="548640"/>
-          </a:xfrm>
-          <a:prstGeom prst="rect">
-            <a:avLst/>
-          </a:prstGeom>
-          <a:noFill/>
-          <a:ln/>
-        </p:spPr>
-        <p:txBody>
-          <a:bodyPr wrap="square" rtlCol="0" anchor="ctr"/>
-          <a:lstStyle/>
-          <a:p>
-            <a:pPr marL="0" indent="0">
-              <a:buNone/>
-            </a:pPr>
-            <a:r>
-              <a:rPr lang="en-US" sz="2200" b="1" dirty="0">
-                <a:solidFill>
-                  <a:srgbClr val="1B5E20"/>
-                </a:solidFill>
-                <a:latin typeface="Helvetica" pitchFamily="34" charset="0"/>
-                <a:ea typeface="Helvetica" pitchFamily="34" charset="-122"/>
-                <a:cs typeface="Helvetica" pitchFamily="34" charset="-120"/>
-              </a:rPr>
-              <a:t>OUTSOURCE</a:t>
-            </a:r>
-            <a:endParaRPr lang="en-US" sz="2200" dirty="0"/>
-          </a:p>
-        </p:txBody>
-      </p:sp>
-      <p:sp>
-        <p:nvSpPr>
-          <p:cNvPr id="8" name="Text 6"/>
-          <p:cNvSpPr/>
-          <p:nvPr/>
-        </p:nvSpPr>
-        <p:spPr>
-          <a:xfrm>
-            <a:off x="777240" y="1965960"/>
-            <a:ext cx="5166360" cy="4114800"/>
-          </a:xfrm>
-          <a:prstGeom prst="rect">
-            <a:avLst/>
-          </a:prstGeom>
-          <a:noFill/>
-          <a:ln/>
-        </p:spPr>
-        <p:txBody>
-          <a:bodyPr wrap="square" rtlCol="0" anchor="t"/>
-          <a:lstStyle/>
-          <a:p>
-            <a:pPr marL="342900" indent="-342900">
-              <a:spcAft>
-                <a:spcPts val="600"/>
-              </a:spcAft>
-              <a:buSzPct val="100000"/>
-              <a:buChar char="■"/>
-            </a:pPr>
-            <a:r>
-              <a:rPr lang="en-US" sz="1800" dirty="0">
-                <a:solidFill>
-                  <a:srgbClr val="1A1A1A"/>
-                </a:solidFill>
-                <a:latin typeface="Helvetica" pitchFamily="34" charset="0"/>
-                <a:ea typeface="Helvetica" pitchFamily="34" charset="-122"/>
-                <a:cs typeface="Helvetica" pitchFamily="34" charset="-120"/>
-              </a:rPr>
-              <a:t>Bán giờ công</a:t>
-            </a:r>
-            <a:endParaRPr lang="en-US" sz="1800" dirty="0"/>
-          </a:p>
-          <a:p>
-            <a:pPr marL="342900" indent="-342900">
-              <a:spcAft>
-                <a:spcPts val="600"/>
-              </a:spcAft>
-              <a:buSzPct val="100000"/>
-              <a:buChar char="■"/>
-            </a:pPr>
-            <a:r>
-              <a:rPr lang="en-US" sz="1800" dirty="0">
-                <a:solidFill>
-                  <a:srgbClr val="1A1A1A"/>
-                </a:solidFill>
-                <a:latin typeface="Helvetica" pitchFamily="34" charset="0"/>
-                <a:ea typeface="Helvetica" pitchFamily="34" charset="-122"/>
-                <a:cs typeface="Helvetica" pitchFamily="34" charset="-120"/>
-              </a:rPr>
-              <a:t>Thu nhập tuyến tính (người × giờ)</a:t>
-            </a:r>
-            <a:endParaRPr lang="en-US" sz="1800" dirty="0"/>
-          </a:p>
-          <a:p>
-            <a:pPr marL="342900" indent="-342900">
-              <a:spcAft>
-                <a:spcPts val="600"/>
-              </a:spcAft>
-              <a:buSzPct val="100000"/>
-              <a:buChar char="■"/>
-            </a:pPr>
-            <a:r>
-              <a:rPr lang="en-US" sz="1800" dirty="0">
-                <a:solidFill>
-                  <a:srgbClr val="1A1A1A"/>
-                </a:solidFill>
-                <a:latin typeface="Helvetica" pitchFamily="34" charset="0"/>
-                <a:ea typeface="Helvetica" pitchFamily="34" charset="-122"/>
-                <a:cs typeface="Helvetica" pitchFamily="34" charset="-120"/>
-              </a:rPr>
-              <a:t>Chắc chắn, ổn định</a:t>
-            </a:r>
-            <a:endParaRPr lang="en-US" sz="1800" dirty="0"/>
-          </a:p>
-          <a:p>
-            <a:pPr marL="342900" indent="-342900">
-              <a:spcAft>
-                <a:spcPts val="600"/>
-              </a:spcAft>
-              <a:buSzPct val="100000"/>
-              <a:buChar char="■"/>
-            </a:pPr>
-            <a:r>
-              <a:rPr lang="en-US" sz="1800" dirty="0">
-                <a:solidFill>
-                  <a:srgbClr val="1A1A1A"/>
-                </a:solidFill>
-                <a:latin typeface="Helvetica" pitchFamily="34" charset="0"/>
-                <a:ea typeface="Helvetica" pitchFamily="34" charset="-122"/>
-                <a:cs typeface="Helvetica" pitchFamily="34" charset="-120"/>
-              </a:rPr>
-              <a:t>Học quy trình enterprise nhanh</a:t>
-            </a:r>
-            <a:endParaRPr lang="en-US" sz="1800" dirty="0"/>
-          </a:p>
-          <a:p>
-            <a:pPr marL="342900" indent="-342900">
-              <a:spcAft>
-                <a:spcPts val="600"/>
-              </a:spcAft>
-              <a:buSzPct val="100000"/>
-              <a:buChar char="■"/>
-            </a:pPr>
-            <a:r>
-              <a:rPr lang="en-US" sz="1800" dirty="0">
-                <a:solidFill>
-                  <a:srgbClr val="1A1A1A"/>
-                </a:solidFill>
-                <a:latin typeface="Helvetica" pitchFamily="34" charset="0"/>
-                <a:ea typeface="Helvetica" pitchFamily="34" charset="-122"/>
-                <a:cs typeface="Helvetica" pitchFamily="34" charset="-120"/>
-              </a:rPr>
-              <a:t>Tiếp xúc client quốc tế</a:t>
-            </a:r>
-            <a:endParaRPr lang="en-US" sz="1800" dirty="0"/>
-          </a:p>
-        </p:txBody>
-      </p:sp>
-      <p:sp>
-        <p:nvSpPr>
-          <p:cNvPr id="9" name="Shape 7"/>
-          <p:cNvSpPr/>
-          <p:nvPr/>
-        </p:nvSpPr>
-        <p:spPr>
-          <a:xfrm>
-            <a:off x="6217920" y="1280160"/>
-            <a:ext cx="5577840" cy="4937760"/>
-          </a:xfrm>
-          <a:prstGeom prst="rect">
-            <a:avLst/>
-          </a:prstGeom>
-          <a:solidFill>
-            <a:srgbClr val="FFFFFF"/>
-          </a:solidFill>
-          <a:ln w="12700">
-            <a:solidFill>
-              <a:srgbClr val="97BC62"/>
-            </a:solidFill>
-            <a:prstDash val="solid"/>
-          </a:ln>
-        </p:spPr>
-      </p:sp>
-      <p:sp>
-        <p:nvSpPr>
-          <p:cNvPr id="10" name="Text 8"/>
-          <p:cNvSpPr/>
-          <p:nvPr/>
-        </p:nvSpPr>
-        <p:spPr>
-          <a:xfrm>
-            <a:off x="6400800" y="1417320"/>
-            <a:ext cx="5303520" cy="548640"/>
-          </a:xfrm>
-          <a:prstGeom prst="rect">
-            <a:avLst/>
-          </a:prstGeom>
-          <a:noFill/>
-          <a:ln/>
-        </p:spPr>
-        <p:txBody>
-          <a:bodyPr wrap="square" rtlCol="0" anchor="ctr"/>
-          <a:lstStyle/>
-          <a:p>
-            <a:pPr marL="0" indent="0">
-              <a:buNone/>
-            </a:pPr>
-            <a:r>
-              <a:rPr lang="en-US" sz="2200" b="1" dirty="0">
-                <a:solidFill>
-                  <a:srgbClr val="1B5E20"/>
-                </a:solidFill>
-                <a:latin typeface="Helvetica" pitchFamily="34" charset="0"/>
-                <a:ea typeface="Helvetica" pitchFamily="34" charset="-122"/>
-                <a:cs typeface="Helvetica" pitchFamily="34" charset="-120"/>
-              </a:rPr>
-              <a:t>PRODUCT</a:t>
-            </a:r>
-            <a:endParaRPr lang="en-US" sz="2200" dirty="0"/>
-          </a:p>
-        </p:txBody>
-      </p:sp>
-      <p:sp>
-        <p:nvSpPr>
-          <p:cNvPr id="11" name="Text 9"/>
-          <p:cNvSpPr/>
-          <p:nvPr/>
-        </p:nvSpPr>
-        <p:spPr>
-          <a:xfrm>
-            <a:off x="6537960" y="1965960"/>
-            <a:ext cx="5166360" cy="4114800"/>
-          </a:xfrm>
-          <a:prstGeom prst="rect">
-            <a:avLst/>
-          </a:prstGeom>
-          <a:noFill/>
-          <a:ln/>
-        </p:spPr>
-        <p:txBody>
-          <a:bodyPr wrap="square" rtlCol="0" anchor="t"/>
-          <a:lstStyle/>
-          <a:p>
-            <a:pPr marL="342900" indent="-342900">
-              <a:spcAft>
-                <a:spcPts val="600"/>
-              </a:spcAft>
-              <a:buSzPct val="100000"/>
-              <a:buChar char="■"/>
-            </a:pPr>
-            <a:r>
-              <a:rPr lang="en-US" sz="1800" dirty="0">
-                <a:solidFill>
-                  <a:srgbClr val="1A1A1A"/>
-                </a:solidFill>
-                <a:latin typeface="Helvetica" pitchFamily="34" charset="0"/>
-                <a:ea typeface="Helvetica" pitchFamily="34" charset="-122"/>
-                <a:cs typeface="Helvetica" pitchFamily="34" charset="-120"/>
-              </a:rPr>
-              <a:t>Bán sản phẩm</a:t>
-            </a:r>
-            <a:endParaRPr lang="en-US" sz="1800" dirty="0"/>
-          </a:p>
-          <a:p>
-            <a:pPr marL="342900" indent="-342900">
-              <a:spcAft>
-                <a:spcPts val="600"/>
-              </a:spcAft>
-              <a:buSzPct val="100000"/>
-              <a:buChar char="■"/>
-            </a:pPr>
-            <a:r>
-              <a:rPr lang="en-US" sz="1800" dirty="0">
-                <a:solidFill>
-                  <a:srgbClr val="1A1A1A"/>
-                </a:solidFill>
-                <a:latin typeface="Helvetica" pitchFamily="34" charset="0"/>
-                <a:ea typeface="Helvetica" pitchFamily="34" charset="-122"/>
-                <a:cs typeface="Helvetica" pitchFamily="34" charset="-120"/>
-              </a:rPr>
-              <a:t>Thu nhập có thể scale phi tuyến</a:t>
-            </a:r>
-            <a:endParaRPr lang="en-US" sz="1800" dirty="0"/>
-          </a:p>
-          <a:p>
-            <a:pPr marL="342900" indent="-342900">
-              <a:spcAft>
-                <a:spcPts val="600"/>
-              </a:spcAft>
-              <a:buSzPct val="100000"/>
-              <a:buChar char="■"/>
-            </a:pPr>
-            <a:r>
-              <a:rPr lang="en-US" sz="1800" dirty="0">
-                <a:solidFill>
-                  <a:srgbClr val="1A1A1A"/>
-                </a:solidFill>
-                <a:latin typeface="Helvetica" pitchFamily="34" charset="0"/>
-                <a:ea typeface="Helvetica" pitchFamily="34" charset="-122"/>
-                <a:cs typeface="Helvetica" pitchFamily="34" charset="-120"/>
-              </a:rPr>
-              <a:t>Rủi ro cao, upside lớn</a:t>
-            </a:r>
-            <a:endParaRPr lang="en-US" sz="1800" dirty="0"/>
-          </a:p>
-          <a:p>
-            <a:pPr marL="342900" indent="-342900">
-              <a:spcAft>
-                <a:spcPts val="600"/>
-              </a:spcAft>
-              <a:buSzPct val="100000"/>
-              <a:buChar char="■"/>
-            </a:pPr>
-            <a:r>
-              <a:rPr lang="en-US" sz="1800" dirty="0">
-                <a:solidFill>
-                  <a:srgbClr val="1A1A1A"/>
-                </a:solidFill>
-                <a:latin typeface="Helvetica" pitchFamily="34" charset="0"/>
-                <a:ea typeface="Helvetica" pitchFamily="34" charset="-122"/>
-                <a:cs typeface="Helvetica" pitchFamily="34" charset="-120"/>
-              </a:rPr>
-              <a:t>Học toàn diện hơn (PM · marketing · ops)</a:t>
-            </a:r>
-            <a:endParaRPr lang="en-US" sz="1800" dirty="0"/>
-          </a:p>
-          <a:p>
-            <a:pPr marL="342900" indent="-342900">
-              <a:spcAft>
-                <a:spcPts val="600"/>
-              </a:spcAft>
-              <a:buSzPct val="100000"/>
-              <a:buChar char="■"/>
-            </a:pPr>
-            <a:r>
-              <a:rPr lang="en-US" sz="1800" dirty="0">
-                <a:solidFill>
-                  <a:srgbClr val="1A1A1A"/>
-                </a:solidFill>
-                <a:latin typeface="Helvetica" pitchFamily="34" charset="0"/>
-                <a:ea typeface="Helvetica" pitchFamily="34" charset="-122"/>
-                <a:cs typeface="Helvetica" pitchFamily="34" charset="-120"/>
-              </a:rPr>
-              <a:t>Có 'chủ quyền' với app của mình</a:t>
-            </a:r>
-            <a:endParaRPr lang="en-US" sz="1800" dirty="0"/>
-          </a:p>
-        </p:txBody>
-      </p:sp>
-      <p:sp>
-        <p:nvSpPr>
-          <p:cNvPr id="12" name="Text 10"/>
           <p:cNvSpPr/>
           <p:nvPr/>
         </p:nvSpPr>
@@ -11376,6 +11244,574 @@
 
 <file path=ppt/slides/slide20.xml><?xml version="1.0" encoding="utf-8"?>
 <p:sld xmlns:a="http://schemas.openxmlformats.org/drawingml/2006/main" xmlns:r="http://schemas.openxmlformats.org/officeDocument/2006/relationships" xmlns:p="http://schemas.openxmlformats.org/presentationml/2006/main">
+  <p:cSld name="Slide 20">
+    <p:bg>
+      <p:bgPr>
+        <a:solidFill>
+          <a:srgbClr val="F7FBF6"/>
+        </a:solidFill>
+        <a:effectLst/>
+      </p:bgPr>
+    </p:bg>
+    <p:spTree>
+      <p:nvGrpSpPr>
+        <p:cNvPr id="1" name=""/>
+        <p:cNvGrpSpPr/>
+        <p:nvPr/>
+      </p:nvGrpSpPr>
+      <p:grpSpPr>
+        <a:xfrm>
+          <a:off x="0" y="0"/>
+          <a:ext cx="0" cy="0"/>
+          <a:chOff x="0" y="0"/>
+          <a:chExt cx="0" cy="0"/>
+        </a:xfrm>
+      </p:grpSpPr>
+      <p:sp>
+        <p:nvSpPr>
+          <p:cNvPr id="2" name="Shape 0"/>
+          <p:cNvSpPr/>
+          <p:nvPr/>
+        </p:nvSpPr>
+        <p:spPr>
+          <a:xfrm>
+            <a:off x="0" y="0"/>
+            <a:ext cx="164592" cy="6858000"/>
+          </a:xfrm>
+          <a:prstGeom prst="rect">
+            <a:avLst/>
+          </a:prstGeom>
+          <a:solidFill>
+            <a:srgbClr val="2E7D32"/>
+          </a:solidFill>
+          <a:ln w="12700">
+            <a:solidFill>
+              <a:srgbClr val="2E7D32"/>
+            </a:solidFill>
+            <a:prstDash val="solid"/>
+          </a:ln>
+        </p:spPr>
+      </p:sp>
+      <p:sp>
+        <p:nvSpPr>
+          <p:cNvPr id="3" name="Shape 1"/>
+          <p:cNvSpPr/>
+          <p:nvPr/>
+        </p:nvSpPr>
+        <p:spPr>
+          <a:xfrm>
+            <a:off x="11521440" y="0"/>
+            <a:ext cx="640080" cy="164592"/>
+          </a:xfrm>
+          <a:prstGeom prst="rect">
+            <a:avLst/>
+          </a:prstGeom>
+          <a:solidFill>
+            <a:srgbClr val="2E7D32"/>
+          </a:solidFill>
+          <a:ln w="12700">
+            <a:solidFill>
+              <a:srgbClr val="2E7D32"/>
+            </a:solidFill>
+            <a:prstDash val="solid"/>
+          </a:ln>
+        </p:spPr>
+      </p:sp>
+      <p:sp>
+        <p:nvSpPr>
+          <p:cNvPr id="4" name="Text 2"/>
+          <p:cNvSpPr/>
+          <p:nvPr/>
+        </p:nvSpPr>
+        <p:spPr>
+          <a:xfrm>
+            <a:off x="457200" y="320040"/>
+            <a:ext cx="11430000" cy="731520"/>
+          </a:xfrm>
+          <a:prstGeom prst="rect">
+            <a:avLst/>
+          </a:prstGeom>
+          <a:noFill/>
+          <a:ln/>
+        </p:spPr>
+        <p:txBody>
+          <a:bodyPr wrap="square" rtlCol="0" anchor="ctr"/>
+          <a:lstStyle/>
+          <a:p>
+            <a:pPr marL="0" indent="0">
+              <a:buNone/>
+            </a:pPr>
+            <a:r>
+              <a:rPr lang="en-US" sz="3200" b="1" dirty="0">
+                <a:solidFill>
+                  <a:srgbClr val="1B5E20"/>
+                </a:solidFill>
+                <a:latin typeface="Helvetica" pitchFamily="34" charset="0"/>
+                <a:ea typeface="Helvetica" pitchFamily="34" charset="-122"/>
+                <a:cs typeface="Helvetica" pitchFamily="34" charset="-120"/>
+              </a:rPr>
+              <a:t>Outsource ≠ Product</a:t>
+            </a:r>
+            <a:endParaRPr lang="en-US" sz="3200" dirty="0"/>
+          </a:p>
+        </p:txBody>
+      </p:sp>
+      <p:sp>
+        <p:nvSpPr>
+          <p:cNvPr id="5" name="Shape 3"/>
+          <p:cNvSpPr/>
+          <p:nvPr/>
+        </p:nvSpPr>
+        <p:spPr>
+          <a:xfrm>
+            <a:off x="457200" y="1005840"/>
+            <a:ext cx="1371600" cy="54864"/>
+          </a:xfrm>
+          <a:prstGeom prst="rect">
+            <a:avLst/>
+          </a:prstGeom>
+          <a:solidFill>
+            <a:srgbClr val="2E7D32"/>
+          </a:solidFill>
+          <a:ln w="12700">
+            <a:solidFill>
+              <a:srgbClr val="2E7D32"/>
+            </a:solidFill>
+            <a:prstDash val="solid"/>
+          </a:ln>
+        </p:spPr>
+      </p:sp>
+      <p:sp>
+        <p:nvSpPr>
+          <p:cNvPr id="6" name="Shape 4"/>
+          <p:cNvSpPr/>
+          <p:nvPr/>
+        </p:nvSpPr>
+        <p:spPr>
+          <a:xfrm>
+            <a:off x="457200" y="1280160"/>
+            <a:ext cx="5577840" cy="4937760"/>
+          </a:xfrm>
+          <a:prstGeom prst="rect">
+            <a:avLst/>
+          </a:prstGeom>
+          <a:solidFill>
+            <a:srgbClr val="FFFFFF"/>
+          </a:solidFill>
+          <a:ln w="12700">
+            <a:solidFill>
+              <a:srgbClr val="97BC62"/>
+            </a:solidFill>
+            <a:prstDash val="solid"/>
+          </a:ln>
+        </p:spPr>
+      </p:sp>
+      <p:sp>
+        <p:nvSpPr>
+          <p:cNvPr id="7" name="Text 5"/>
+          <p:cNvSpPr/>
+          <p:nvPr/>
+        </p:nvSpPr>
+        <p:spPr>
+          <a:xfrm>
+            <a:off x="640080" y="1417320"/>
+            <a:ext cx="5303520" cy="548640"/>
+          </a:xfrm>
+          <a:prstGeom prst="rect">
+            <a:avLst/>
+          </a:prstGeom>
+          <a:noFill/>
+          <a:ln/>
+        </p:spPr>
+        <p:txBody>
+          <a:bodyPr wrap="square" rtlCol="0" anchor="ctr"/>
+          <a:lstStyle/>
+          <a:p>
+            <a:pPr marL="0" indent="0">
+              <a:buNone/>
+            </a:pPr>
+            <a:r>
+              <a:rPr lang="en-US" sz="2200" b="1" dirty="0">
+                <a:solidFill>
+                  <a:srgbClr val="1B5E20"/>
+                </a:solidFill>
+                <a:latin typeface="Helvetica" pitchFamily="34" charset="0"/>
+                <a:ea typeface="Helvetica" pitchFamily="34" charset="-122"/>
+                <a:cs typeface="Helvetica" pitchFamily="34" charset="-120"/>
+              </a:rPr>
+              <a:t>OUTSOURCE</a:t>
+            </a:r>
+            <a:endParaRPr lang="en-US" sz="2200" dirty="0"/>
+          </a:p>
+        </p:txBody>
+      </p:sp>
+      <p:sp>
+        <p:nvSpPr>
+          <p:cNvPr id="8" name="Text 6"/>
+          <p:cNvSpPr/>
+          <p:nvPr/>
+        </p:nvSpPr>
+        <p:spPr>
+          <a:xfrm>
+            <a:off x="777240" y="1965960"/>
+            <a:ext cx="5166360" cy="4114800"/>
+          </a:xfrm>
+          <a:prstGeom prst="rect">
+            <a:avLst/>
+          </a:prstGeom>
+          <a:noFill/>
+          <a:ln/>
+        </p:spPr>
+        <p:txBody>
+          <a:bodyPr wrap="square" rtlCol="0" anchor="t"/>
+          <a:lstStyle/>
+          <a:p>
+            <a:pPr marL="342900" indent="-342900">
+              <a:spcAft>
+                <a:spcPts val="600"/>
+              </a:spcAft>
+              <a:buSzPct val="100000"/>
+              <a:buChar char="■"/>
+            </a:pPr>
+            <a:r>
+              <a:rPr lang="en-US" sz="1800" dirty="0">
+                <a:solidFill>
+                  <a:srgbClr val="1A1A1A"/>
+                </a:solidFill>
+                <a:latin typeface="Helvetica" pitchFamily="34" charset="0"/>
+                <a:ea typeface="Helvetica" pitchFamily="34" charset="-122"/>
+                <a:cs typeface="Helvetica" pitchFamily="34" charset="-120"/>
+              </a:rPr>
+              <a:t>Bán giờ công</a:t>
+            </a:r>
+            <a:endParaRPr lang="en-US" sz="1800" dirty="0"/>
+          </a:p>
+          <a:p>
+            <a:pPr marL="342900" indent="-342900">
+              <a:spcAft>
+                <a:spcPts val="600"/>
+              </a:spcAft>
+              <a:buSzPct val="100000"/>
+              <a:buChar char="■"/>
+            </a:pPr>
+            <a:r>
+              <a:rPr lang="en-US" sz="1800" dirty="0">
+                <a:solidFill>
+                  <a:srgbClr val="1A1A1A"/>
+                </a:solidFill>
+                <a:latin typeface="Helvetica" pitchFamily="34" charset="0"/>
+                <a:ea typeface="Helvetica" pitchFamily="34" charset="-122"/>
+                <a:cs typeface="Helvetica" pitchFamily="34" charset="-120"/>
+              </a:rPr>
+              <a:t>Thu nhập tuyến tính (người × giờ)</a:t>
+            </a:r>
+            <a:endParaRPr lang="en-US" sz="1800" dirty="0"/>
+          </a:p>
+          <a:p>
+            <a:pPr marL="342900" indent="-342900">
+              <a:spcAft>
+                <a:spcPts val="600"/>
+              </a:spcAft>
+              <a:buSzPct val="100000"/>
+              <a:buChar char="■"/>
+            </a:pPr>
+            <a:r>
+              <a:rPr lang="en-US" sz="1800" dirty="0">
+                <a:solidFill>
+                  <a:srgbClr val="1A1A1A"/>
+                </a:solidFill>
+                <a:latin typeface="Helvetica" pitchFamily="34" charset="0"/>
+                <a:ea typeface="Helvetica" pitchFamily="34" charset="-122"/>
+                <a:cs typeface="Helvetica" pitchFamily="34" charset="-120"/>
+              </a:rPr>
+              <a:t>Chắc chắn, ổn định</a:t>
+            </a:r>
+            <a:endParaRPr lang="en-US" sz="1800" dirty="0"/>
+          </a:p>
+          <a:p>
+            <a:pPr marL="342900" indent="-342900">
+              <a:spcAft>
+                <a:spcPts val="600"/>
+              </a:spcAft>
+              <a:buSzPct val="100000"/>
+              <a:buChar char="■"/>
+            </a:pPr>
+            <a:r>
+              <a:rPr lang="en-US" sz="1800" dirty="0">
+                <a:solidFill>
+                  <a:srgbClr val="1A1A1A"/>
+                </a:solidFill>
+                <a:latin typeface="Helvetica" pitchFamily="34" charset="0"/>
+                <a:ea typeface="Helvetica" pitchFamily="34" charset="-122"/>
+                <a:cs typeface="Helvetica" pitchFamily="34" charset="-120"/>
+              </a:rPr>
+              <a:t>Học quy trình enterprise nhanh</a:t>
+            </a:r>
+            <a:endParaRPr lang="en-US" sz="1800" dirty="0"/>
+          </a:p>
+          <a:p>
+            <a:pPr marL="342900" indent="-342900">
+              <a:spcAft>
+                <a:spcPts val="600"/>
+              </a:spcAft>
+              <a:buSzPct val="100000"/>
+              <a:buChar char="■"/>
+            </a:pPr>
+            <a:r>
+              <a:rPr lang="en-US" sz="1800" dirty="0">
+                <a:solidFill>
+                  <a:srgbClr val="1A1A1A"/>
+                </a:solidFill>
+                <a:latin typeface="Helvetica" pitchFamily="34" charset="0"/>
+                <a:ea typeface="Helvetica" pitchFamily="34" charset="-122"/>
+                <a:cs typeface="Helvetica" pitchFamily="34" charset="-120"/>
+              </a:rPr>
+              <a:t>Tiếp xúc client quốc tế</a:t>
+            </a:r>
+            <a:endParaRPr lang="en-US" sz="1800" dirty="0"/>
+          </a:p>
+        </p:txBody>
+      </p:sp>
+      <p:sp>
+        <p:nvSpPr>
+          <p:cNvPr id="9" name="Shape 7"/>
+          <p:cNvSpPr/>
+          <p:nvPr/>
+        </p:nvSpPr>
+        <p:spPr>
+          <a:xfrm>
+            <a:off x="6217920" y="1280160"/>
+            <a:ext cx="5577840" cy="4937760"/>
+          </a:xfrm>
+          <a:prstGeom prst="rect">
+            <a:avLst/>
+          </a:prstGeom>
+          <a:solidFill>
+            <a:srgbClr val="FFFFFF"/>
+          </a:solidFill>
+          <a:ln w="12700">
+            <a:solidFill>
+              <a:srgbClr val="97BC62"/>
+            </a:solidFill>
+            <a:prstDash val="solid"/>
+          </a:ln>
+        </p:spPr>
+      </p:sp>
+      <p:sp>
+        <p:nvSpPr>
+          <p:cNvPr id="10" name="Text 8"/>
+          <p:cNvSpPr/>
+          <p:nvPr/>
+        </p:nvSpPr>
+        <p:spPr>
+          <a:xfrm>
+            <a:off x="6400800" y="1417320"/>
+            <a:ext cx="5303520" cy="548640"/>
+          </a:xfrm>
+          <a:prstGeom prst="rect">
+            <a:avLst/>
+          </a:prstGeom>
+          <a:noFill/>
+          <a:ln/>
+        </p:spPr>
+        <p:txBody>
+          <a:bodyPr wrap="square" rtlCol="0" anchor="ctr"/>
+          <a:lstStyle/>
+          <a:p>
+            <a:pPr marL="0" indent="0">
+              <a:buNone/>
+            </a:pPr>
+            <a:r>
+              <a:rPr lang="en-US" sz="2200" b="1" dirty="0">
+                <a:solidFill>
+                  <a:srgbClr val="1B5E20"/>
+                </a:solidFill>
+                <a:latin typeface="Helvetica" pitchFamily="34" charset="0"/>
+                <a:ea typeface="Helvetica" pitchFamily="34" charset="-122"/>
+                <a:cs typeface="Helvetica" pitchFamily="34" charset="-120"/>
+              </a:rPr>
+              <a:t>PRODUCT</a:t>
+            </a:r>
+            <a:endParaRPr lang="en-US" sz="2200" dirty="0"/>
+          </a:p>
+        </p:txBody>
+      </p:sp>
+      <p:sp>
+        <p:nvSpPr>
+          <p:cNvPr id="11" name="Text 9"/>
+          <p:cNvSpPr/>
+          <p:nvPr/>
+        </p:nvSpPr>
+        <p:spPr>
+          <a:xfrm>
+            <a:off x="6537960" y="1965960"/>
+            <a:ext cx="5166360" cy="4114800"/>
+          </a:xfrm>
+          <a:prstGeom prst="rect">
+            <a:avLst/>
+          </a:prstGeom>
+          <a:noFill/>
+          <a:ln/>
+        </p:spPr>
+        <p:txBody>
+          <a:bodyPr wrap="square" rtlCol="0" anchor="t"/>
+          <a:lstStyle/>
+          <a:p>
+            <a:pPr marL="342900" indent="-342900">
+              <a:spcAft>
+                <a:spcPts val="600"/>
+              </a:spcAft>
+              <a:buSzPct val="100000"/>
+              <a:buChar char="■"/>
+            </a:pPr>
+            <a:r>
+              <a:rPr lang="en-US" sz="1800" dirty="0">
+                <a:solidFill>
+                  <a:srgbClr val="1A1A1A"/>
+                </a:solidFill>
+                <a:latin typeface="Helvetica" pitchFamily="34" charset="0"/>
+                <a:ea typeface="Helvetica" pitchFamily="34" charset="-122"/>
+                <a:cs typeface="Helvetica" pitchFamily="34" charset="-120"/>
+              </a:rPr>
+              <a:t>Bán sản phẩm</a:t>
+            </a:r>
+            <a:endParaRPr lang="en-US" sz="1800" dirty="0"/>
+          </a:p>
+          <a:p>
+            <a:pPr marL="342900" indent="-342900">
+              <a:spcAft>
+                <a:spcPts val="600"/>
+              </a:spcAft>
+              <a:buSzPct val="100000"/>
+              <a:buChar char="■"/>
+            </a:pPr>
+            <a:r>
+              <a:rPr lang="en-US" sz="1800" dirty="0">
+                <a:solidFill>
+                  <a:srgbClr val="1A1A1A"/>
+                </a:solidFill>
+                <a:latin typeface="Helvetica" pitchFamily="34" charset="0"/>
+                <a:ea typeface="Helvetica" pitchFamily="34" charset="-122"/>
+                <a:cs typeface="Helvetica" pitchFamily="34" charset="-120"/>
+              </a:rPr>
+              <a:t>Thu nhập có thể scale phi tuyến</a:t>
+            </a:r>
+            <a:endParaRPr lang="en-US" sz="1800" dirty="0"/>
+          </a:p>
+          <a:p>
+            <a:pPr marL="342900" indent="-342900">
+              <a:spcAft>
+                <a:spcPts val="600"/>
+              </a:spcAft>
+              <a:buSzPct val="100000"/>
+              <a:buChar char="■"/>
+            </a:pPr>
+            <a:r>
+              <a:rPr lang="en-US" sz="1800" dirty="0">
+                <a:solidFill>
+                  <a:srgbClr val="1A1A1A"/>
+                </a:solidFill>
+                <a:latin typeface="Helvetica" pitchFamily="34" charset="0"/>
+                <a:ea typeface="Helvetica" pitchFamily="34" charset="-122"/>
+                <a:cs typeface="Helvetica" pitchFamily="34" charset="-120"/>
+              </a:rPr>
+              <a:t>Rủi ro cao, upside lớn</a:t>
+            </a:r>
+            <a:endParaRPr lang="en-US" sz="1800" dirty="0"/>
+          </a:p>
+          <a:p>
+            <a:pPr marL="342900" indent="-342900">
+              <a:spcAft>
+                <a:spcPts val="600"/>
+              </a:spcAft>
+              <a:buSzPct val="100000"/>
+              <a:buChar char="■"/>
+            </a:pPr>
+            <a:r>
+              <a:rPr lang="en-US" sz="1800" dirty="0">
+                <a:solidFill>
+                  <a:srgbClr val="1A1A1A"/>
+                </a:solidFill>
+                <a:latin typeface="Helvetica" pitchFamily="34" charset="0"/>
+                <a:ea typeface="Helvetica" pitchFamily="34" charset="-122"/>
+                <a:cs typeface="Helvetica" pitchFamily="34" charset="-120"/>
+              </a:rPr>
+              <a:t>Học toàn diện hơn (PM · marketing · ops)</a:t>
+            </a:r>
+            <a:endParaRPr lang="en-US" sz="1800" dirty="0"/>
+          </a:p>
+          <a:p>
+            <a:pPr marL="342900" indent="-342900">
+              <a:spcAft>
+                <a:spcPts val="600"/>
+              </a:spcAft>
+              <a:buSzPct val="100000"/>
+              <a:buChar char="■"/>
+            </a:pPr>
+            <a:r>
+              <a:rPr lang="en-US" sz="1800" dirty="0">
+                <a:solidFill>
+                  <a:srgbClr val="1A1A1A"/>
+                </a:solidFill>
+                <a:latin typeface="Helvetica" pitchFamily="34" charset="0"/>
+                <a:ea typeface="Helvetica" pitchFamily="34" charset="-122"/>
+                <a:cs typeface="Helvetica" pitchFamily="34" charset="-120"/>
+              </a:rPr>
+              <a:t>Có 'chủ quyền' với app của mình</a:t>
+            </a:r>
+            <a:endParaRPr lang="en-US" sz="1800" dirty="0"/>
+          </a:p>
+        </p:txBody>
+      </p:sp>
+      <p:sp>
+        <p:nvSpPr>
+          <p:cNvPr id="12" name="Text 10"/>
+          <p:cNvSpPr/>
+          <p:nvPr/>
+        </p:nvSpPr>
+        <p:spPr>
+          <a:xfrm>
+            <a:off x="7772400" y="6492240"/>
+            <a:ext cx="4114800" cy="274320"/>
+          </a:xfrm>
+          <a:prstGeom prst="rect">
+            <a:avLst/>
+          </a:prstGeom>
+          <a:noFill/>
+          <a:ln/>
+        </p:spPr>
+        <p:txBody>
+          <a:bodyPr wrap="square" rtlCol="0" anchor="ctr"/>
+          <a:lstStyle/>
+          <a:p>
+            <a:pPr marL="0" indent="0" algn="r">
+              <a:buNone/>
+            </a:pPr>
+            <a:r>
+              <a:rPr lang="en-US" sz="1100" dirty="0">
+                <a:solidFill>
+                  <a:srgbClr val="555555"/>
+                </a:solidFill>
+                <a:latin typeface="Helvetica" pitchFamily="34" charset="0"/>
+                <a:ea typeface="Helvetica" pitchFamily="34" charset="-122"/>
+                <a:cs typeface="Helvetica" pitchFamily="34" charset="-120"/>
+              </a:rPr>
+              <a:t>Nguyễn Quế Lân · VNGalaxy</a:t>
+            </a:r>
+            <a:endParaRPr lang="en-US" sz="1100" dirty="0"/>
+          </a:p>
+        </p:txBody>
+      </p:sp>
+    </p:spTree>
+  </p:cSld>
+  <p:clrMapOvr>
+    <a:masterClrMapping/>
+  </p:clrMapOvr>
+</p:sld>
+</file>
+
+<file path=ppt/slides/slide21.xml><?xml version="1.0" encoding="utf-8"?>
+<p:sld xmlns:a="http://schemas.openxmlformats.org/drawingml/2006/main" xmlns:r="http://schemas.openxmlformats.org/officeDocument/2006/relationships" xmlns:p="http://schemas.openxmlformats.org/presentationml/2006/main">
   <p:cSld name="Slide 21">
     <p:bg>
       <p:bgPr>
@@ -12226,7 +12662,7 @@
 </p:sld>
 </file>
 
-<file path=ppt/slides/slide21.xml><?xml version="1.0" encoding="utf-8"?>
+<file path=ppt/slides/slide22.xml><?xml version="1.0" encoding="utf-8"?>
 <p:sld xmlns:a="http://schemas.openxmlformats.org/drawingml/2006/main" xmlns:r="http://schemas.openxmlformats.org/officeDocument/2006/relationships" xmlns:p="http://schemas.openxmlformats.org/presentationml/2006/main">
   <p:cSld name="Slide 22">
     <p:bg>
@@ -13282,7 +13718,7 @@
 </p:sld>
 </file>
 
-<file path=ppt/slides/slide22.xml><?xml version="1.0" encoding="utf-8"?>
+<file path=ppt/slides/slide23.xml><?xml version="1.0" encoding="utf-8"?>
 <p:sld xmlns:a="http://schemas.openxmlformats.org/drawingml/2006/main" xmlns:r="http://schemas.openxmlformats.org/officeDocument/2006/relationships" xmlns:p="http://schemas.openxmlformats.org/presentationml/2006/main">
   <p:cSld name="Slide 23">
     <p:bg>
@@ -14775,7 +15211,7 @@
 </p:sld>
 </file>
 
-<file path=ppt/slides/slide23.xml><?xml version="1.0" encoding="utf-8"?>
+<file path=ppt/slides/slide24.xml><?xml version="1.0" encoding="utf-8"?>
 <p:sld xmlns:a="http://schemas.openxmlformats.org/drawingml/2006/main" xmlns:r="http://schemas.openxmlformats.org/officeDocument/2006/relationships" xmlns:p="http://schemas.openxmlformats.org/presentationml/2006/main">
   <p:cSld name="Slide 24">
     <p:bg>
@@ -15301,7 +15737,7 @@
 </p:sld>
 </file>
 
-<file path=ppt/slides/slide24.xml><?xml version="1.0" encoding="utf-8"?>
+<file path=ppt/slides/slide25.xml><?xml version="1.0" encoding="utf-8"?>
 <p:sld xmlns:a="http://schemas.openxmlformats.org/drawingml/2006/main" xmlns:r="http://schemas.openxmlformats.org/officeDocument/2006/relationships" xmlns:p="http://schemas.openxmlformats.org/presentationml/2006/main">
   <p:cSld name="Slide 25">
     <p:bg>
@@ -16080,7 +16516,7 @@
 </p:sld>
 </file>
 
-<file path=ppt/slides/slide25.xml><?xml version="1.0" encoding="utf-8"?>
+<file path=ppt/slides/slide26.xml><?xml version="1.0" encoding="utf-8"?>
 <p:sld xmlns:a="http://schemas.openxmlformats.org/drawingml/2006/main" xmlns:r="http://schemas.openxmlformats.org/officeDocument/2006/relationships" xmlns:p="http://schemas.openxmlformats.org/presentationml/2006/main">
   <p:cSld name="Slide 26">
     <p:bg>
@@ -16648,7 +17084,7 @@
 </p:sld>
 </file>
 
-<file path=ppt/slides/slide26.xml><?xml version="1.0" encoding="utf-8"?>
+<file path=ppt/slides/slide27.xml><?xml version="1.0" encoding="utf-8"?>
 <p:sld xmlns:a="http://schemas.openxmlformats.org/drawingml/2006/main" xmlns:r="http://schemas.openxmlformats.org/officeDocument/2006/relationships" xmlns:p="http://schemas.openxmlformats.org/presentationml/2006/main">
   <p:cSld name="Slide 27">
     <p:bg>
@@ -16809,7 +17245,7 @@
 </p:sld>
 </file>
 
-<file path=ppt/slides/slide27.xml><?xml version="1.0" encoding="utf-8"?>
+<file path=ppt/slides/slide28.xml><?xml version="1.0" encoding="utf-8"?>
 <p:sld xmlns:a="http://schemas.openxmlformats.org/drawingml/2006/main" xmlns:r="http://schemas.openxmlformats.org/officeDocument/2006/relationships" xmlns:p="http://schemas.openxmlformats.org/presentationml/2006/main">
   <p:cSld name="Slide 29">
     <p:bg>
@@ -17145,20 +17581,18 @@
 </p:sld>
 </file>
 
-<file path=ppt/slides/slide28.xml><?xml version="1.0" encoding="utf-8"?>
+<file path=ppt/slides/slide29.xml><?xml version="1.0" encoding="utf-8"?>
 <p:sld xmlns:a="http://schemas.openxmlformats.org/drawingml/2006/main" xmlns:r="http://schemas.openxmlformats.org/officeDocument/2006/relationships" xmlns:p="http://schemas.openxmlformats.org/presentationml/2006/main">
-  <p:cSld name="Slide 28">
-    <p:bg>
-      <p:bgPr>
-        <a:solidFill>
-          <a:srgbClr val="F7FBF6"/>
-        </a:solidFill>
-        <a:effectLst/>
-      </p:bgPr>
-    </p:bg>
+  <p:cSld>
     <p:spTree>
       <p:nvGrpSpPr>
-        <p:cNvPr id="1" name=""/>
+        <p:cNvPr id="1" name="">
+          <a:extLst>
+            <a:ext uri="{FF2B5EF4-FFF2-40B4-BE49-F238E27FC236}">
+              <a16:creationId xmlns:a16="http://schemas.microsoft.com/office/drawing/2014/main" id="{F225655A-D65C-8C89-56A1-4BED67488032}"/>
+            </a:ext>
+          </a:extLst>
+        </p:cNvPr>
         <p:cNvGrpSpPr/>
         <p:nvPr/>
       </p:nvGrpSpPr>
@@ -17172,7 +17606,13 @@
       </p:grpSpPr>
       <p:sp>
         <p:nvSpPr>
-          <p:cNvPr id="2" name="Shape 0"/>
+          <p:cNvPr id="2" name="Shape 0">
+            <a:extLst>
+              <a:ext uri="{FF2B5EF4-FFF2-40B4-BE49-F238E27FC236}">
+                <a16:creationId xmlns:a16="http://schemas.microsoft.com/office/drawing/2014/main" id="{422B0744-5869-D2CA-3098-EB43958F29F3}"/>
+              </a:ext>
+            </a:extLst>
+          </p:cNvPr>
           <p:cNvSpPr/>
           <p:nvPr/>
         </p:nvSpPr>
@@ -17194,10 +17634,23 @@
             <a:prstDash val="solid"/>
           </a:ln>
         </p:spPr>
-      </p:sp>
-      <p:sp>
-        <p:nvSpPr>
-          <p:cNvPr id="3" name="Shape 1"/>
+        <p:txBody>
+          <a:bodyPr/>
+          <a:lstStyle/>
+          <a:p>
+            <a:endParaRPr/>
+          </a:p>
+        </p:txBody>
+      </p:sp>
+      <p:sp>
+        <p:nvSpPr>
+          <p:cNvPr id="3" name="Shape 1">
+            <a:extLst>
+              <a:ext uri="{FF2B5EF4-FFF2-40B4-BE49-F238E27FC236}">
+                <a16:creationId xmlns:a16="http://schemas.microsoft.com/office/drawing/2014/main" id="{AF086803-D107-F690-9BA1-74C1A09A7C0C}"/>
+              </a:ext>
+            </a:extLst>
+          </p:cNvPr>
           <p:cNvSpPr/>
           <p:nvPr/>
         </p:nvSpPr>
@@ -17219,33 +17672,46 @@
             <a:prstDash val="solid"/>
           </a:ln>
         </p:spPr>
-      </p:sp>
-      <p:sp>
-        <p:nvSpPr>
-          <p:cNvPr id="4" name="Text 2"/>
-          <p:cNvSpPr/>
-          <p:nvPr/>
-        </p:nvSpPr>
-        <p:spPr>
-          <a:xfrm>
-            <a:off x="457200" y="320040"/>
-            <a:ext cx="11430000" cy="731520"/>
-          </a:xfrm>
-          <a:prstGeom prst="rect">
-            <a:avLst/>
-          </a:prstGeom>
-          <a:noFill/>
-          <a:ln/>
-        </p:spPr>
-        <p:txBody>
-          <a:bodyPr wrap="square" rtlCol="0" anchor="ctr"/>
-          <a:lstStyle/>
-          <a:p>
-            <a:pPr marL="0" indent="0">
-              <a:buNone/>
-            </a:pPr>
-            <a:r>
-              <a:rPr lang="en-US" sz="3200" b="1" dirty="0">
+        <p:txBody>
+          <a:bodyPr/>
+          <a:lstStyle/>
+          <a:p>
+            <a:endParaRPr/>
+          </a:p>
+        </p:txBody>
+      </p:sp>
+      <p:sp>
+        <p:nvSpPr>
+          <p:cNvPr id="4" name="Text 2">
+            <a:extLst>
+              <a:ext uri="{FF2B5EF4-FFF2-40B4-BE49-F238E27FC236}">
+                <a16:creationId xmlns:a16="http://schemas.microsoft.com/office/drawing/2014/main" id="{00EA4D4A-383D-AFFC-A9AE-4786984FC038}"/>
+              </a:ext>
+            </a:extLst>
+          </p:cNvPr>
+          <p:cNvSpPr/>
+          <p:nvPr/>
+        </p:nvSpPr>
+        <p:spPr>
+          <a:xfrm>
+            <a:off x="444125" y="2731770"/>
+            <a:ext cx="11430000" cy="1394460"/>
+          </a:xfrm>
+          <a:prstGeom prst="rect">
+            <a:avLst/>
+          </a:prstGeom>
+          <a:noFill/>
+          <a:ln/>
+        </p:spPr>
+        <p:txBody>
+          <a:bodyPr wrap="square" rtlCol="0" anchor="ctr"/>
+          <a:lstStyle/>
+          <a:p>
+            <a:pPr marL="0" indent="0" algn="ctr">
+              <a:buNone/>
+            </a:pPr>
+            <a:r>
+              <a:rPr lang="en-US" sz="8000" b="1" dirty="0">
                 <a:solidFill>
                   <a:srgbClr val="1B5E20"/>
                 </a:solidFill>
@@ -17255,13 +17721,19 @@
               </a:rPr>
               <a:t>Q&amp;A</a:t>
             </a:r>
-            <a:endParaRPr lang="en-US" sz="3200" dirty="0"/>
-          </a:p>
-        </p:txBody>
-      </p:sp>
-      <p:sp>
-        <p:nvSpPr>
-          <p:cNvPr id="5" name="Shape 3"/>
+            <a:endParaRPr lang="en-US" sz="8000" dirty="0"/>
+          </a:p>
+        </p:txBody>
+      </p:sp>
+      <p:sp>
+        <p:nvSpPr>
+          <p:cNvPr id="5" name="Shape 3">
+            <a:extLst>
+              <a:ext uri="{FF2B5EF4-FFF2-40B4-BE49-F238E27FC236}">
+                <a16:creationId xmlns:a16="http://schemas.microsoft.com/office/drawing/2014/main" id="{8601580C-2414-F160-42D1-BCE517180CD0}"/>
+              </a:ext>
+            </a:extLst>
+          </p:cNvPr>
           <p:cNvSpPr/>
           <p:nvPr/>
         </p:nvSpPr>
@@ -17283,160 +17755,23 @@
             <a:prstDash val="solid"/>
           </a:ln>
         </p:spPr>
-      </p:sp>
-      <p:sp>
-        <p:nvSpPr>
-          <p:cNvPr id="6" name="Text 4"/>
-          <p:cNvSpPr/>
-          <p:nvPr/>
-        </p:nvSpPr>
-        <p:spPr>
-          <a:xfrm>
-            <a:off x="640080" y="1280160"/>
-            <a:ext cx="10972800" cy="4937760"/>
-          </a:xfrm>
-          <a:prstGeom prst="rect">
-            <a:avLst/>
-          </a:prstGeom>
-          <a:noFill/>
-          <a:ln/>
-        </p:spPr>
-        <p:txBody>
-          <a:bodyPr wrap="square" rtlCol="0" anchor="t"/>
-          <a:lstStyle/>
-          <a:p>
-            <a:pPr marL="342900" indent="-342900">
-              <a:spcAft>
-                <a:spcPts val="600"/>
-              </a:spcAft>
-              <a:buSzPct val="100000"/>
-              <a:buChar char="■"/>
-            </a:pPr>
-            <a:r>
-              <a:rPr lang="en-US" sz="2200" dirty="0">
-                <a:solidFill>
-                  <a:srgbClr val="1A1A1A"/>
-                </a:solidFill>
-                <a:latin typeface="Helvetica" pitchFamily="34" charset="0"/>
-                <a:ea typeface="Helvetica" pitchFamily="34" charset="-122"/>
-                <a:cs typeface="Helvetica" pitchFamily="34" charset="-120"/>
-              </a:rPr>
-              <a:t>Bạn nào đã thử apply intern iOS?</a:t>
-            </a:r>
-            <a:endParaRPr lang="en-US" sz="2200" dirty="0"/>
-          </a:p>
-          <a:p>
-            <a:pPr marL="342900" indent="-342900">
-              <a:spcAft>
-                <a:spcPts val="600"/>
-              </a:spcAft>
-              <a:buSzPct val="100000"/>
-              <a:buChar char="■"/>
-            </a:pPr>
-            <a:r>
-              <a:rPr lang="en-US" sz="2200" dirty="0">
-                <a:solidFill>
-                  <a:srgbClr val="1A1A1A"/>
-                </a:solidFill>
-                <a:latin typeface="Helvetica" pitchFamily="34" charset="0"/>
-                <a:ea typeface="Helvetica" pitchFamily="34" charset="-122"/>
-                <a:cs typeface="Helvetica" pitchFamily="34" charset="-120"/>
-              </a:rPr>
-              <a:t>Khó khăn lớn nhất khi đi phỏng vấn là gì?</a:t>
-            </a:r>
-            <a:endParaRPr lang="en-US" sz="2200" dirty="0"/>
-          </a:p>
-          <a:p>
-            <a:pPr marL="342900" indent="-342900">
-              <a:spcAft>
-                <a:spcPts val="600"/>
-              </a:spcAft>
-              <a:buSzPct val="100000"/>
-              <a:buChar char="■"/>
-            </a:pPr>
-            <a:r>
-              <a:rPr lang="en-US" sz="2200" dirty="0">
-                <a:solidFill>
-                  <a:srgbClr val="1A1A1A"/>
-                </a:solidFill>
-                <a:latin typeface="Helvetica" pitchFamily="34" charset="0"/>
-                <a:ea typeface="Helvetica" pitchFamily="34" charset="-122"/>
-                <a:cs typeface="Helvetica" pitchFamily="34" charset="-120"/>
-              </a:rPr>
-              <a:t>Bạn muốn hỏi gì về quy trình </a:t>
-            </a:r>
-            <a:r>
-              <a:rPr lang="en-US" sz="2200" dirty="0" err="1">
-                <a:solidFill>
-                  <a:srgbClr val="1A1A1A"/>
-                </a:solidFill>
-                <a:latin typeface="Helvetica" pitchFamily="34" charset="0"/>
-                <a:ea typeface="Helvetica" pitchFamily="34" charset="-122"/>
-                <a:cs typeface="Helvetica" pitchFamily="34" charset="-120"/>
-              </a:rPr>
-              <a:t>tuyển</a:t>
-            </a:r>
-            <a:r>
-              <a:rPr lang="en-US" sz="2200" dirty="0">
-                <a:solidFill>
-                  <a:srgbClr val="1A1A1A"/>
-                </a:solidFill>
-                <a:latin typeface="Helvetica" pitchFamily="34" charset="0"/>
-                <a:ea typeface="Helvetica" pitchFamily="34" charset="-122"/>
-                <a:cs typeface="Helvetica" pitchFamily="34" charset="-120"/>
-              </a:rPr>
-              <a:t> </a:t>
-            </a:r>
-            <a:r>
-              <a:rPr lang="en-US" sz="2200" dirty="0" err="1">
-                <a:solidFill>
-                  <a:srgbClr val="1A1A1A"/>
-                </a:solidFill>
-                <a:latin typeface="Helvetica" pitchFamily="34" charset="0"/>
-                <a:ea typeface="Helvetica" pitchFamily="34" charset="-122"/>
-                <a:cs typeface="Helvetica" pitchFamily="34" charset="-120"/>
-              </a:rPr>
-              <a:t>dụng</a:t>
-            </a:r>
-            <a:r>
-              <a:rPr lang="en-US" sz="2200" dirty="0">
-                <a:solidFill>
-                  <a:srgbClr val="1A1A1A"/>
-                </a:solidFill>
-                <a:latin typeface="Helvetica" pitchFamily="34" charset="0"/>
-                <a:ea typeface="Helvetica" pitchFamily="34" charset="-122"/>
-                <a:cs typeface="Helvetica" pitchFamily="34" charset="-120"/>
-              </a:rPr>
-              <a:t>, công nghệ?</a:t>
-            </a:r>
-            <a:endParaRPr lang="en-US" sz="2200" dirty="0"/>
-          </a:p>
-          <a:p>
-            <a:pPr marL="342900" indent="-342900">
-              <a:spcAft>
-                <a:spcPts val="600"/>
-              </a:spcAft>
-              <a:buSzPct val="100000"/>
-              <a:buChar char="■"/>
-            </a:pPr>
-            <a:r>
-              <a:rPr lang="en-US" sz="2200" b="1" dirty="0">
-                <a:solidFill>
-                  <a:srgbClr val="1A1A1A"/>
-                </a:solidFill>
-                <a:latin typeface="Helvetica" pitchFamily="34" charset="0"/>
-                <a:ea typeface="Helvetica" pitchFamily="34" charset="-122"/>
-                <a:cs typeface="Helvetica" pitchFamily="34" charset="-120"/>
-              </a:rPr>
-              <a:t>Đặt câu hỏi — không có câu nào ngớ ngẩn</a:t>
-            </a:r>
-            <a:endParaRPr lang="en-US" sz="2200" dirty="0"/>
-          </a:p>
-        </p:txBody>
-      </p:sp>
-      <p:sp>
-        <p:nvSpPr>
-          <p:cNvPr id="7" name="Text 5"/>
+        <p:txBody>
+          <a:bodyPr/>
+          <a:lstStyle/>
+          <a:p>
+            <a:endParaRPr/>
+          </a:p>
+        </p:txBody>
+      </p:sp>
+      <p:sp>
+        <p:nvSpPr>
+          <p:cNvPr id="7" name="Text 5">
+            <a:extLst>
+              <a:ext uri="{FF2B5EF4-FFF2-40B4-BE49-F238E27FC236}">
+                <a16:creationId xmlns:a16="http://schemas.microsoft.com/office/drawing/2014/main" id="{3EC38C0A-778E-0001-2E16-E48721154B76}"/>
+              </a:ext>
+            </a:extLst>
+          </p:cNvPr>
           <p:cNvSpPr/>
           <p:nvPr/>
         </p:nvSpPr>
@@ -17478,7 +17813,7 @@
           <p:cNvPr id="8" name="TextBox 7">
             <a:extLst>
               <a:ext uri="{FF2B5EF4-FFF2-40B4-BE49-F238E27FC236}">
-                <a16:creationId xmlns:a16="http://schemas.microsoft.com/office/drawing/2014/main" id="{274E0852-256C-B93C-A977-B843B92B9F4A}"/>
+                <a16:creationId xmlns:a16="http://schemas.microsoft.com/office/drawing/2014/main" id="{277CE652-1D6E-30CC-4DC1-A3A675A26FF3}"/>
               </a:ext>
             </a:extLst>
           </p:cNvPr>
@@ -17506,245 +17841,11 @@
         </p:txBody>
       </p:sp>
     </p:spTree>
-  </p:cSld>
-  <p:clrMapOvr>
-    <a:masterClrMapping/>
-  </p:clrMapOvr>
-</p:sld>
-</file>
-
-<file path=ppt/slides/slide29.xml><?xml version="1.0" encoding="utf-8"?>
-<p:sld xmlns:a="http://schemas.openxmlformats.org/drawingml/2006/main" xmlns:r="http://schemas.openxmlformats.org/officeDocument/2006/relationships" xmlns:p="http://schemas.openxmlformats.org/presentationml/2006/main">
-  <p:cSld name="Slide 30">
-    <p:bg>
-      <p:bgPr>
-        <a:solidFill>
-          <a:srgbClr val="1B3A1F"/>
-        </a:solidFill>
-        <a:effectLst/>
-      </p:bgPr>
-    </p:bg>
-    <p:spTree>
-      <p:nvGrpSpPr>
-        <p:cNvPr id="1" name=""/>
-        <p:cNvGrpSpPr/>
-        <p:nvPr/>
-      </p:nvGrpSpPr>
-      <p:grpSpPr>
-        <a:xfrm>
-          <a:off x="0" y="0"/>
-          <a:ext cx="0" cy="0"/>
-          <a:chOff x="0" y="0"/>
-          <a:chExt cx="0" cy="0"/>
-        </a:xfrm>
-      </p:grpSpPr>
-      <p:sp>
-        <p:nvSpPr>
-          <p:cNvPr id="2" name="Shape 0"/>
-          <p:cNvSpPr/>
-          <p:nvPr/>
-        </p:nvSpPr>
-        <p:spPr>
-          <a:xfrm>
-            <a:off x="0" y="0"/>
-            <a:ext cx="164592" cy="6858000"/>
-          </a:xfrm>
-          <a:prstGeom prst="rect">
-            <a:avLst/>
-          </a:prstGeom>
-          <a:solidFill>
-            <a:srgbClr val="97BC62"/>
-          </a:solidFill>
-          <a:ln w="12700">
-            <a:solidFill>
-              <a:srgbClr val="97BC62"/>
-            </a:solidFill>
-            <a:prstDash val="solid"/>
-          </a:ln>
-        </p:spPr>
-      </p:sp>
-      <p:sp>
-        <p:nvSpPr>
-          <p:cNvPr id="3" name="Shape 1"/>
-          <p:cNvSpPr/>
-          <p:nvPr/>
-        </p:nvSpPr>
-        <p:spPr>
-          <a:xfrm>
-            <a:off x="11521440" y="0"/>
-            <a:ext cx="640080" cy="164592"/>
-          </a:xfrm>
-          <a:prstGeom prst="rect">
-            <a:avLst/>
-          </a:prstGeom>
-          <a:solidFill>
-            <a:srgbClr val="97BC62"/>
-          </a:solidFill>
-          <a:ln w="12700">
-            <a:solidFill>
-              <a:srgbClr val="97BC62"/>
-            </a:solidFill>
-            <a:prstDash val="solid"/>
-          </a:ln>
-        </p:spPr>
-      </p:sp>
-      <p:sp>
-        <p:nvSpPr>
-          <p:cNvPr id="4" name="Text 2"/>
-          <p:cNvSpPr/>
-          <p:nvPr/>
-        </p:nvSpPr>
-        <p:spPr>
-          <a:xfrm>
-            <a:off x="731520" y="2286000"/>
-            <a:ext cx="10972800" cy="1371600"/>
-          </a:xfrm>
-          <a:prstGeom prst="rect">
-            <a:avLst/>
-          </a:prstGeom>
-          <a:noFill/>
-          <a:ln/>
-        </p:spPr>
-        <p:txBody>
-          <a:bodyPr wrap="square" rtlCol="0" anchor="ctr"/>
-          <a:lstStyle/>
-          <a:p>
-            <a:pPr marL="0" indent="0">
-              <a:buNone/>
-            </a:pPr>
-            <a:r>
-              <a:rPr lang="en-US" sz="7200" b="1" dirty="0">
-                <a:solidFill>
-                  <a:srgbClr val="FFFFFF"/>
-                </a:solidFill>
-                <a:latin typeface="Helvetica" pitchFamily="34" charset="0"/>
-                <a:ea typeface="Helvetica" pitchFamily="34" charset="-122"/>
-                <a:cs typeface="Helvetica" pitchFamily="34" charset="-120"/>
-              </a:rPr>
-              <a:t>Cảm ơn!</a:t>
-            </a:r>
-            <a:endParaRPr lang="en-US" sz="7200" dirty="0"/>
-          </a:p>
-        </p:txBody>
-      </p:sp>
-      <p:sp>
-        <p:nvSpPr>
-          <p:cNvPr id="5" name="Text 3"/>
-          <p:cNvSpPr/>
-          <p:nvPr/>
-        </p:nvSpPr>
-        <p:spPr>
-          <a:xfrm>
-            <a:off x="731520" y="3657600"/>
-            <a:ext cx="10972800" cy="731520"/>
-          </a:xfrm>
-          <a:prstGeom prst="rect">
-            <a:avLst/>
-          </a:prstGeom>
-          <a:noFill/>
-          <a:ln/>
-        </p:spPr>
-        <p:txBody>
-          <a:bodyPr wrap="square" rtlCol="0" anchor="ctr"/>
-          <a:lstStyle/>
-          <a:p>
-            <a:pPr marL="0" indent="0">
-              <a:buNone/>
-            </a:pPr>
-            <a:r>
-              <a:rPr lang="en-US" sz="2400" dirty="0">
-                <a:solidFill>
-                  <a:srgbClr val="97BC62"/>
-                </a:solidFill>
-                <a:latin typeface="Helvetica" pitchFamily="34" charset="0"/>
-                <a:ea typeface="Helvetica" pitchFamily="34" charset="-122"/>
-                <a:cs typeface="Helvetica" pitchFamily="34" charset="-120"/>
-              </a:rPr>
-              <a:t>Hẹn gặp lại ở ca 2 — góc nhìn Product &amp; Indie</a:t>
-            </a:r>
-            <a:endParaRPr lang="en-US" sz="2400" dirty="0"/>
-          </a:p>
-        </p:txBody>
-      </p:sp>
-      <p:sp>
-        <p:nvSpPr>
-          <p:cNvPr id="6" name="Text 4"/>
-          <p:cNvSpPr/>
-          <p:nvPr/>
-        </p:nvSpPr>
-        <p:spPr>
-          <a:xfrm>
-            <a:off x="731520" y="5029200"/>
-            <a:ext cx="10972800" cy="548640"/>
-          </a:xfrm>
-          <a:prstGeom prst="rect">
-            <a:avLst/>
-          </a:prstGeom>
-          <a:noFill/>
-          <a:ln/>
-        </p:spPr>
-        <p:txBody>
-          <a:bodyPr wrap="square" rtlCol="0" anchor="ctr"/>
-          <a:lstStyle/>
-          <a:p>
-            <a:pPr marL="0" indent="0">
-              <a:buNone/>
-            </a:pPr>
-            <a:r>
-              <a:rPr lang="en-US" sz="2000" b="1" dirty="0">
-                <a:solidFill>
-                  <a:srgbClr val="FFFFFF"/>
-                </a:solidFill>
-                <a:latin typeface="Helvetica" pitchFamily="34" charset="0"/>
-                <a:ea typeface="Helvetica" pitchFamily="34" charset="-122"/>
-                <a:cs typeface="Helvetica" pitchFamily="34" charset="-120"/>
-              </a:rPr>
-              <a:t>Nguyễn Quế Lân · VNGalaxy</a:t>
-            </a:r>
-            <a:endParaRPr lang="en-US" sz="2000" dirty="0"/>
-          </a:p>
-        </p:txBody>
-      </p:sp>
-      <p:sp>
-        <p:nvSpPr>
-          <p:cNvPr id="7" name="Text 5"/>
-          <p:cNvSpPr/>
-          <p:nvPr/>
-        </p:nvSpPr>
-        <p:spPr>
-          <a:xfrm>
-            <a:off x="7772400" y="6492240"/>
-            <a:ext cx="4114800" cy="274320"/>
-          </a:xfrm>
-          <a:prstGeom prst="rect">
-            <a:avLst/>
-          </a:prstGeom>
-          <a:noFill/>
-          <a:ln/>
-        </p:spPr>
-        <p:txBody>
-          <a:bodyPr wrap="square" rtlCol="0" anchor="ctr"/>
-          <a:lstStyle/>
-          <a:p>
-            <a:pPr marL="0" indent="0" algn="r">
-              <a:buNone/>
-            </a:pPr>
-            <a:r>
-              <a:rPr lang="en-US" sz="1100" dirty="0">
-                <a:solidFill>
-                  <a:srgbClr val="97BC62"/>
-                </a:solidFill>
-                <a:latin typeface="Helvetica" pitchFamily="34" charset="0"/>
-                <a:ea typeface="Helvetica" pitchFamily="34" charset="-122"/>
-                <a:cs typeface="Helvetica" pitchFamily="34" charset="-120"/>
-              </a:rPr>
-              <a:t>Nguyễn Quế Lân · VNGalaxy</a:t>
-            </a:r>
-            <a:endParaRPr lang="en-US" sz="1100" dirty="0"/>
-          </a:p>
-        </p:txBody>
-      </p:sp>
-    </p:spTree>
+    <p:extLst>
+      <p:ext uri="{BB962C8B-B14F-4D97-AF65-F5344CB8AC3E}">
+        <p14:creationId xmlns:p14="http://schemas.microsoft.com/office/powerpoint/2010/main" val="1262537194"/>
+      </p:ext>
+    </p:extLst>
   </p:cSld>
   <p:clrMapOvr>
     <a:masterClrMapping/>
@@ -18046,6 +18147,900 @@
               <a:rPr lang="en-US" sz="1100" dirty="0">
                 <a:solidFill>
                   <a:srgbClr val="555555"/>
+                </a:solidFill>
+                <a:latin typeface="Helvetica" pitchFamily="34" charset="0"/>
+                <a:ea typeface="Helvetica" pitchFamily="34" charset="-122"/>
+                <a:cs typeface="Helvetica" pitchFamily="34" charset="-120"/>
+              </a:rPr>
+              <a:t>Nguyễn Quế Lân · VNGalaxy</a:t>
+            </a:r>
+            <a:endParaRPr lang="en-US" sz="1100" dirty="0"/>
+          </a:p>
+        </p:txBody>
+      </p:sp>
+    </p:spTree>
+  </p:cSld>
+  <p:clrMapOvr>
+    <a:masterClrMapping/>
+  </p:clrMapOvr>
+</p:sld>
+</file>
+
+<file path=ppt/slides/slide30.xml><?xml version="1.0" encoding="utf-8"?>
+<p:sld xmlns:a="http://schemas.openxmlformats.org/drawingml/2006/main" xmlns:r="http://schemas.openxmlformats.org/officeDocument/2006/relationships" xmlns:p="http://schemas.openxmlformats.org/presentationml/2006/main">
+  <p:cSld name="Slide 28">
+    <p:bg>
+      <p:bgPr>
+        <a:solidFill>
+          <a:srgbClr val="F7FBF6"/>
+        </a:solidFill>
+        <a:effectLst/>
+      </p:bgPr>
+    </p:bg>
+    <p:spTree>
+      <p:nvGrpSpPr>
+        <p:cNvPr id="1" name=""/>
+        <p:cNvGrpSpPr/>
+        <p:nvPr/>
+      </p:nvGrpSpPr>
+      <p:grpSpPr>
+        <a:xfrm>
+          <a:off x="0" y="0"/>
+          <a:ext cx="0" cy="0"/>
+          <a:chOff x="0" y="0"/>
+          <a:chExt cx="0" cy="0"/>
+        </a:xfrm>
+      </p:grpSpPr>
+      <p:sp>
+        <p:nvSpPr>
+          <p:cNvPr id="2" name="Shape 0"/>
+          <p:cNvSpPr/>
+          <p:nvPr/>
+        </p:nvSpPr>
+        <p:spPr>
+          <a:xfrm>
+            <a:off x="0" y="0"/>
+            <a:ext cx="164592" cy="6858000"/>
+          </a:xfrm>
+          <a:prstGeom prst="rect">
+            <a:avLst/>
+          </a:prstGeom>
+          <a:solidFill>
+            <a:srgbClr val="2E7D32"/>
+          </a:solidFill>
+          <a:ln w="12700">
+            <a:solidFill>
+              <a:srgbClr val="2E7D32"/>
+            </a:solidFill>
+            <a:prstDash val="solid"/>
+          </a:ln>
+        </p:spPr>
+        <p:txBody>
+          <a:bodyPr/>
+          <a:lstStyle/>
+          <a:p>
+            <a:endParaRPr/>
+          </a:p>
+        </p:txBody>
+      </p:sp>
+      <p:sp>
+        <p:nvSpPr>
+          <p:cNvPr id="3" name="Shape 1"/>
+          <p:cNvSpPr/>
+          <p:nvPr/>
+        </p:nvSpPr>
+        <p:spPr>
+          <a:xfrm>
+            <a:off x="11521440" y="0"/>
+            <a:ext cx="640080" cy="164592"/>
+          </a:xfrm>
+          <a:prstGeom prst="rect">
+            <a:avLst/>
+          </a:prstGeom>
+          <a:solidFill>
+            <a:srgbClr val="2E7D32"/>
+          </a:solidFill>
+          <a:ln w="12700">
+            <a:solidFill>
+              <a:srgbClr val="2E7D32"/>
+            </a:solidFill>
+            <a:prstDash val="solid"/>
+          </a:ln>
+        </p:spPr>
+        <p:txBody>
+          <a:bodyPr/>
+          <a:lstStyle/>
+          <a:p>
+            <a:endParaRPr/>
+          </a:p>
+        </p:txBody>
+      </p:sp>
+      <p:sp>
+        <p:nvSpPr>
+          <p:cNvPr id="4" name="Text 2"/>
+          <p:cNvSpPr/>
+          <p:nvPr/>
+        </p:nvSpPr>
+        <p:spPr>
+          <a:xfrm>
+            <a:off x="457200" y="320040"/>
+            <a:ext cx="11430000" cy="731520"/>
+          </a:xfrm>
+          <a:prstGeom prst="rect">
+            <a:avLst/>
+          </a:prstGeom>
+          <a:noFill/>
+          <a:ln/>
+        </p:spPr>
+        <p:txBody>
+          <a:bodyPr wrap="square" rtlCol="0" anchor="ctr"/>
+          <a:lstStyle/>
+          <a:p>
+            <a:pPr marL="0" indent="0">
+              <a:buNone/>
+            </a:pPr>
+            <a:r>
+              <a:rPr lang="en-US" sz="3200" b="1" dirty="0">
+                <a:solidFill>
+                  <a:srgbClr val="1B5E20"/>
+                </a:solidFill>
+                <a:latin typeface="Helvetica" pitchFamily="34" charset="0"/>
+                <a:ea typeface="Helvetica" pitchFamily="34" charset="-122"/>
+                <a:cs typeface="Helvetica" pitchFamily="34" charset="-120"/>
+              </a:rPr>
+              <a:t>Q&amp;A</a:t>
+            </a:r>
+            <a:endParaRPr lang="en-US" sz="3200" dirty="0"/>
+          </a:p>
+        </p:txBody>
+      </p:sp>
+      <p:sp>
+        <p:nvSpPr>
+          <p:cNvPr id="5" name="Shape 3"/>
+          <p:cNvSpPr/>
+          <p:nvPr/>
+        </p:nvSpPr>
+        <p:spPr>
+          <a:xfrm>
+            <a:off x="457200" y="1005840"/>
+            <a:ext cx="1371600" cy="54864"/>
+          </a:xfrm>
+          <a:prstGeom prst="rect">
+            <a:avLst/>
+          </a:prstGeom>
+          <a:solidFill>
+            <a:srgbClr val="2E7D32"/>
+          </a:solidFill>
+          <a:ln w="12700">
+            <a:solidFill>
+              <a:srgbClr val="2E7D32"/>
+            </a:solidFill>
+            <a:prstDash val="solid"/>
+          </a:ln>
+        </p:spPr>
+        <p:txBody>
+          <a:bodyPr/>
+          <a:lstStyle/>
+          <a:p>
+            <a:endParaRPr/>
+          </a:p>
+        </p:txBody>
+      </p:sp>
+      <p:sp>
+        <p:nvSpPr>
+          <p:cNvPr id="6" name="Text 4"/>
+          <p:cNvSpPr/>
+          <p:nvPr/>
+        </p:nvSpPr>
+        <p:spPr>
+          <a:xfrm>
+            <a:off x="640080" y="1280160"/>
+            <a:ext cx="10972800" cy="4937760"/>
+          </a:xfrm>
+          <a:prstGeom prst="rect">
+            <a:avLst/>
+          </a:prstGeom>
+          <a:noFill/>
+          <a:ln/>
+        </p:spPr>
+        <p:txBody>
+          <a:bodyPr wrap="square" rtlCol="0" anchor="t"/>
+          <a:lstStyle/>
+          <a:p>
+            <a:pPr marL="342900" indent="-342900">
+              <a:spcAft>
+                <a:spcPts val="600"/>
+              </a:spcAft>
+              <a:buSzPct val="100000"/>
+              <a:buChar char="■"/>
+            </a:pPr>
+            <a:r>
+              <a:rPr lang="en-US" sz="2200" dirty="0">
+                <a:solidFill>
+                  <a:srgbClr val="1A1A1A"/>
+                </a:solidFill>
+                <a:latin typeface="Helvetica" pitchFamily="34" charset="0"/>
+                <a:ea typeface="Helvetica" pitchFamily="34" charset="-122"/>
+                <a:cs typeface="Helvetica" pitchFamily="34" charset="-120"/>
+              </a:rPr>
+              <a:t>Bạn nào đã thử apply intern iOS?</a:t>
+            </a:r>
+            <a:endParaRPr lang="en-US" sz="2200" dirty="0"/>
+          </a:p>
+          <a:p>
+            <a:pPr marL="342900" indent="-342900">
+              <a:spcAft>
+                <a:spcPts val="600"/>
+              </a:spcAft>
+              <a:buSzPct val="100000"/>
+              <a:buChar char="■"/>
+            </a:pPr>
+            <a:r>
+              <a:rPr lang="en-US" sz="2200" dirty="0">
+                <a:solidFill>
+                  <a:srgbClr val="1A1A1A"/>
+                </a:solidFill>
+                <a:latin typeface="Helvetica" pitchFamily="34" charset="0"/>
+                <a:ea typeface="Helvetica" pitchFamily="34" charset="-122"/>
+                <a:cs typeface="Helvetica" pitchFamily="34" charset="-120"/>
+              </a:rPr>
+              <a:t>Khó khăn lớn nhất khi đi phỏng vấn là gì?</a:t>
+            </a:r>
+            <a:endParaRPr lang="en-US" sz="2200" dirty="0"/>
+          </a:p>
+          <a:p>
+            <a:pPr marL="342900" indent="-342900">
+              <a:spcAft>
+                <a:spcPts val="600"/>
+              </a:spcAft>
+              <a:buSzPct val="100000"/>
+              <a:buChar char="■"/>
+            </a:pPr>
+            <a:r>
+              <a:rPr lang="en-US" sz="2200" dirty="0">
+                <a:solidFill>
+                  <a:srgbClr val="1A1A1A"/>
+                </a:solidFill>
+                <a:latin typeface="Helvetica" pitchFamily="34" charset="0"/>
+                <a:ea typeface="Helvetica" pitchFamily="34" charset="-122"/>
+                <a:cs typeface="Helvetica" pitchFamily="34" charset="-120"/>
+              </a:rPr>
+              <a:t>Bạn muốn hỏi gì về quy trình </a:t>
+            </a:r>
+            <a:r>
+              <a:rPr lang="en-US" sz="2200" dirty="0" err="1">
+                <a:solidFill>
+                  <a:srgbClr val="1A1A1A"/>
+                </a:solidFill>
+                <a:latin typeface="Helvetica" pitchFamily="34" charset="0"/>
+                <a:ea typeface="Helvetica" pitchFamily="34" charset="-122"/>
+                <a:cs typeface="Helvetica" pitchFamily="34" charset="-120"/>
+              </a:rPr>
+              <a:t>tuyển</a:t>
+            </a:r>
+            <a:r>
+              <a:rPr lang="en-US" sz="2200" dirty="0">
+                <a:solidFill>
+                  <a:srgbClr val="1A1A1A"/>
+                </a:solidFill>
+                <a:latin typeface="Helvetica" pitchFamily="34" charset="0"/>
+                <a:ea typeface="Helvetica" pitchFamily="34" charset="-122"/>
+                <a:cs typeface="Helvetica" pitchFamily="34" charset="-120"/>
+              </a:rPr>
+              <a:t> </a:t>
+            </a:r>
+            <a:r>
+              <a:rPr lang="en-US" sz="2200" dirty="0" err="1">
+                <a:solidFill>
+                  <a:srgbClr val="1A1A1A"/>
+                </a:solidFill>
+                <a:latin typeface="Helvetica" pitchFamily="34" charset="0"/>
+                <a:ea typeface="Helvetica" pitchFamily="34" charset="-122"/>
+                <a:cs typeface="Helvetica" pitchFamily="34" charset="-120"/>
+              </a:rPr>
+              <a:t>dụng</a:t>
+            </a:r>
+            <a:r>
+              <a:rPr lang="en-US" sz="2200" dirty="0">
+                <a:solidFill>
+                  <a:srgbClr val="1A1A1A"/>
+                </a:solidFill>
+                <a:latin typeface="Helvetica" pitchFamily="34" charset="0"/>
+                <a:ea typeface="Helvetica" pitchFamily="34" charset="-122"/>
+                <a:cs typeface="Helvetica" pitchFamily="34" charset="-120"/>
+              </a:rPr>
+              <a:t>, công nghệ?</a:t>
+            </a:r>
+            <a:endParaRPr lang="en-US" sz="2200" dirty="0"/>
+          </a:p>
+          <a:p>
+            <a:pPr marL="342900" indent="-342900">
+              <a:spcAft>
+                <a:spcPts val="600"/>
+              </a:spcAft>
+              <a:buSzPct val="100000"/>
+              <a:buChar char="■"/>
+            </a:pPr>
+            <a:r>
+              <a:rPr lang="en-US" sz="2200" b="1" dirty="0">
+                <a:solidFill>
+                  <a:srgbClr val="1A1A1A"/>
+                </a:solidFill>
+                <a:latin typeface="Helvetica" pitchFamily="34" charset="0"/>
+                <a:ea typeface="Helvetica" pitchFamily="34" charset="-122"/>
+                <a:cs typeface="Helvetica" pitchFamily="34" charset="-120"/>
+              </a:rPr>
+              <a:t>Đặt câu hỏi — không có câu nào ngớ ngẩn</a:t>
+            </a:r>
+            <a:endParaRPr lang="en-US" sz="2200" dirty="0"/>
+          </a:p>
+        </p:txBody>
+      </p:sp>
+      <p:sp>
+        <p:nvSpPr>
+          <p:cNvPr id="7" name="Text 5"/>
+          <p:cNvSpPr/>
+          <p:nvPr/>
+        </p:nvSpPr>
+        <p:spPr>
+          <a:xfrm>
+            <a:off x="7772400" y="6492240"/>
+            <a:ext cx="4114800" cy="274320"/>
+          </a:xfrm>
+          <a:prstGeom prst="rect">
+            <a:avLst/>
+          </a:prstGeom>
+          <a:noFill/>
+          <a:ln/>
+        </p:spPr>
+        <p:txBody>
+          <a:bodyPr wrap="square" rtlCol="0" anchor="ctr"/>
+          <a:lstStyle/>
+          <a:p>
+            <a:pPr marL="0" indent="0" algn="r">
+              <a:buNone/>
+            </a:pPr>
+            <a:r>
+              <a:rPr lang="en-US" sz="1100" dirty="0">
+                <a:solidFill>
+                  <a:srgbClr val="555555"/>
+                </a:solidFill>
+                <a:latin typeface="Helvetica" pitchFamily="34" charset="0"/>
+                <a:ea typeface="Helvetica" pitchFamily="34" charset="-122"/>
+                <a:cs typeface="Helvetica" pitchFamily="34" charset="-120"/>
+              </a:rPr>
+              <a:t>Nguyễn Quế Lân · VNGalaxy</a:t>
+            </a:r>
+            <a:endParaRPr lang="en-US" sz="1100" dirty="0"/>
+          </a:p>
+        </p:txBody>
+      </p:sp>
+      <p:sp>
+        <p:nvSpPr>
+          <p:cNvPr id="8" name="TextBox 7">
+            <a:extLst>
+              <a:ext uri="{FF2B5EF4-FFF2-40B4-BE49-F238E27FC236}">
+                <a16:creationId xmlns:a16="http://schemas.microsoft.com/office/drawing/2014/main" id="{274E0852-256C-B93C-A977-B843B92B9F4A}"/>
+              </a:ext>
+            </a:extLst>
+          </p:cNvPr>
+          <p:cNvSpPr txBox="1"/>
+          <p:nvPr/>
+        </p:nvSpPr>
+        <p:spPr>
+          <a:xfrm>
+            <a:off x="2523460" y="4295553"/>
+            <a:ext cx="184731" cy="369332"/>
+          </a:xfrm>
+          <a:prstGeom prst="rect">
+            <a:avLst/>
+          </a:prstGeom>
+          <a:noFill/>
+        </p:spPr>
+        <p:txBody>
+          <a:bodyPr wrap="none" rtlCol="0">
+            <a:spAutoFit/>
+          </a:bodyPr>
+          <a:lstStyle/>
+          <a:p>
+            <a:endParaRPr lang="en-VN" dirty="0"/>
+          </a:p>
+        </p:txBody>
+      </p:sp>
+    </p:spTree>
+  </p:cSld>
+  <p:clrMapOvr>
+    <a:masterClrMapping/>
+  </p:clrMapOvr>
+</p:sld>
+</file>
+
+<file path=ppt/slides/slide31.xml><?xml version="1.0" encoding="utf-8"?>
+<p:sld xmlns:a="http://schemas.openxmlformats.org/drawingml/2006/main" xmlns:r="http://schemas.openxmlformats.org/officeDocument/2006/relationships" xmlns:p="http://schemas.openxmlformats.org/presentationml/2006/main">
+  <p:cSld>
+    <p:bg>
+      <p:bgPr>
+        <a:solidFill>
+          <a:srgbClr val="2E7D32"/>
+        </a:solidFill>
+        <a:effectLst/>
+      </p:bgPr>
+    </p:bg>
+    <p:spTree>
+      <p:nvGrpSpPr>
+        <p:cNvPr id="1" name=""/>
+        <p:cNvGrpSpPr/>
+        <p:nvPr/>
+      </p:nvGrpSpPr>
+      <p:grpSpPr>
+        <a:xfrm>
+          <a:off x="0" y="0"/>
+          <a:ext cx="0" cy="0"/>
+          <a:chOff x="0" y="0"/>
+          <a:chExt cx="0" cy="0"/>
+        </a:xfrm>
+      </p:grpSpPr>
+      <p:sp>
+        <p:nvSpPr>
+          <p:cNvPr id="2" name="Rectangle 1"/>
+          <p:cNvSpPr/>
+          <p:nvPr/>
+        </p:nvSpPr>
+        <p:spPr>
+          <a:xfrm>
+            <a:off x="0" y="5349240"/>
+            <a:ext cx="12192000" cy="1508760"/>
+          </a:xfrm>
+          <a:prstGeom prst="rect">
+            <a:avLst/>
+          </a:prstGeom>
+          <a:solidFill>
+            <a:srgbClr val="1B3A1F"/>
+          </a:solidFill>
+          <a:ln>
+            <a:noFill/>
+          </a:ln>
+        </p:spPr>
+        <p:style>
+          <a:lnRef idx="1">
+            <a:schemeClr val="accent1"/>
+          </a:lnRef>
+          <a:fillRef idx="3">
+            <a:schemeClr val="accent1"/>
+          </a:fillRef>
+          <a:effectRef idx="2">
+            <a:schemeClr val="accent1"/>
+          </a:effectRef>
+          <a:fontRef idx="minor">
+            <a:schemeClr val="lt1"/>
+          </a:fontRef>
+        </p:style>
+        <p:txBody>
+          <a:bodyPr rtlCol="0" anchor="ctr"/>
+          <a:lstStyle/>
+          <a:p>
+            <a:pPr algn="ctr"/>
+            <a:endParaRPr/>
+          </a:p>
+        </p:txBody>
+      </p:sp>
+      <p:sp>
+        <p:nvSpPr>
+          <p:cNvPr id="3" name="TextBox 2"/>
+          <p:cNvSpPr txBox="1"/>
+          <p:nvPr/>
+        </p:nvSpPr>
+        <p:spPr>
+          <a:xfrm>
+            <a:off x="777240" y="512064"/>
+            <a:ext cx="10637520" cy="640080"/>
+          </a:xfrm>
+          <a:prstGeom prst="rect">
+            <a:avLst/>
+          </a:prstGeom>
+          <a:noFill/>
+        </p:spPr>
+        <p:txBody>
+          <a:bodyPr wrap="square" lIns="0" tIns="0" rIns="0" bIns="0">
+            <a:spAutoFit/>
+          </a:bodyPr>
+          <a:lstStyle/>
+          <a:p>
+            <a:pPr algn="ctr"/>
+            <a:r>
+              <a:rPr sz="3400" b="1">
+                <a:solidFill>
+                  <a:srgbClr val="FFFFFF"/>
+                </a:solidFill>
+                <a:latin typeface="Aptos Display"/>
+              </a:rPr>
+              <a:t>Quét mã QR để nhận tài liệu</a:t>
+            </a:r>
+          </a:p>
+        </p:txBody>
+      </p:sp>
+      <p:sp>
+        <p:nvSpPr>
+          <p:cNvPr id="4" name="TextBox 3"/>
+          <p:cNvSpPr txBox="1"/>
+          <p:nvPr/>
+        </p:nvSpPr>
+        <p:spPr>
+          <a:xfrm>
+            <a:off x="914400" y="1170432"/>
+            <a:ext cx="10363200" cy="502920"/>
+          </a:xfrm>
+          <a:prstGeom prst="rect">
+            <a:avLst/>
+          </a:prstGeom>
+          <a:noFill/>
+        </p:spPr>
+        <p:txBody>
+          <a:bodyPr wrap="square" lIns="0" tIns="0" rIns="0" bIns="0">
+            <a:spAutoFit/>
+          </a:bodyPr>
+          <a:lstStyle/>
+          <a:p>
+            <a:pPr algn="ctr"/>
+            <a:r>
+              <a:rPr sz="1900" b="0">
+                <a:solidFill>
+                  <a:srgbClr val="F7FBF6"/>
+                </a:solidFill>
+                <a:latin typeface="Aptos Display"/>
+              </a:rPr>
+              <a:t>Nhập email để nhận tài liệu về lập trình iOS</a:t>
+            </a:r>
+          </a:p>
+        </p:txBody>
+      </p:sp>
+      <p:sp>
+        <p:nvSpPr>
+          <p:cNvPr id="5" name="Rounded Rectangle 4"/>
+          <p:cNvSpPr/>
+          <p:nvPr/>
+        </p:nvSpPr>
+        <p:spPr>
+          <a:xfrm>
+            <a:off x="4178808" y="1792224"/>
+            <a:ext cx="3840480" cy="3840480"/>
+          </a:xfrm>
+          <a:prstGeom prst="roundRect">
+            <a:avLst/>
+          </a:prstGeom>
+          <a:solidFill>
+            <a:srgbClr val="FFFFFF"/>
+          </a:solidFill>
+          <a:ln w="15240">
+            <a:solidFill>
+              <a:srgbClr val="97BC62"/>
+            </a:solidFill>
+          </a:ln>
+        </p:spPr>
+        <p:style>
+          <a:lnRef idx="1">
+            <a:schemeClr val="accent1"/>
+          </a:lnRef>
+          <a:fillRef idx="3">
+            <a:schemeClr val="accent1"/>
+          </a:fillRef>
+          <a:effectRef idx="2">
+            <a:schemeClr val="accent1"/>
+          </a:effectRef>
+          <a:fontRef idx="minor">
+            <a:schemeClr val="lt1"/>
+          </a:fontRef>
+        </p:style>
+        <p:txBody>
+          <a:bodyPr rtlCol="0" anchor="ctr"/>
+          <a:lstStyle/>
+          <a:p>
+            <a:pPr algn="ctr"/>
+            <a:endParaRPr/>
+          </a:p>
+        </p:txBody>
+      </p:sp>
+      <p:pic>
+        <p:nvPicPr>
+          <p:cNvPr id="6" name="Picture 5" descr="qr-ios-materials-form-green.png"/>
+          <p:cNvPicPr>
+            <a:picLocks noChangeAspect="1"/>
+          </p:cNvPicPr>
+          <p:nvPr/>
+        </p:nvPicPr>
+        <p:blipFill>
+          <a:blip r:embed="rId2"/>
+          <a:stretch>
+            <a:fillRect/>
+          </a:stretch>
+        </p:blipFill>
+        <p:spPr>
+          <a:xfrm>
+            <a:off x="4425696" y="2039112"/>
+            <a:ext cx="3346704" cy="3346704"/>
+          </a:xfrm>
+          <a:prstGeom prst="rect">
+            <a:avLst/>
+          </a:prstGeom>
+        </p:spPr>
+      </p:pic>
+      <p:sp>
+        <p:nvSpPr>
+          <p:cNvPr id="7" name="TextBox 6"/>
+          <p:cNvSpPr txBox="1"/>
+          <p:nvPr/>
+        </p:nvSpPr>
+        <p:spPr>
+          <a:xfrm>
+            <a:off x="1828800" y="5806440"/>
+            <a:ext cx="8534400" cy="310896"/>
+          </a:xfrm>
+          <a:prstGeom prst="rect">
+            <a:avLst/>
+          </a:prstGeom>
+          <a:noFill/>
+        </p:spPr>
+        <p:txBody>
+          <a:bodyPr wrap="square" lIns="0" tIns="0" rIns="0" bIns="0">
+            <a:spAutoFit/>
+          </a:bodyPr>
+          <a:lstStyle/>
+          <a:p>
+            <a:pPr algn="ctr"/>
+            <a:r>
+              <a:rPr sz="1000" b="0">
+                <a:solidFill>
+                  <a:srgbClr val="F7FBF6"/>
+                </a:solidFill>
+                <a:latin typeface="Aptos Display"/>
+              </a:rPr>
+              <a:t>https://forms.gle/QwxUtTsD4bLW7uZZ9</a:t>
+            </a:r>
+          </a:p>
+        </p:txBody>
+      </p:sp>
+    </p:spTree>
+  </p:cSld>
+  <p:clrMapOvr>
+    <a:masterClrMapping/>
+  </p:clrMapOvr>
+</p:sld>
+</file>
+
+<file path=ppt/slides/slide32.xml><?xml version="1.0" encoding="utf-8"?>
+<p:sld xmlns:a="http://schemas.openxmlformats.org/drawingml/2006/main" xmlns:r="http://schemas.openxmlformats.org/officeDocument/2006/relationships" xmlns:p="http://schemas.openxmlformats.org/presentationml/2006/main">
+  <p:cSld name="Slide 30">
+    <p:bg>
+      <p:bgPr>
+        <a:solidFill>
+          <a:srgbClr val="1B3A1F"/>
+        </a:solidFill>
+        <a:effectLst/>
+      </p:bgPr>
+    </p:bg>
+    <p:spTree>
+      <p:nvGrpSpPr>
+        <p:cNvPr id="1" name=""/>
+        <p:cNvGrpSpPr/>
+        <p:nvPr/>
+      </p:nvGrpSpPr>
+      <p:grpSpPr>
+        <a:xfrm>
+          <a:off x="0" y="0"/>
+          <a:ext cx="0" cy="0"/>
+          <a:chOff x="0" y="0"/>
+          <a:chExt cx="0" cy="0"/>
+        </a:xfrm>
+      </p:grpSpPr>
+      <p:sp>
+        <p:nvSpPr>
+          <p:cNvPr id="2" name="Shape 0"/>
+          <p:cNvSpPr/>
+          <p:nvPr/>
+        </p:nvSpPr>
+        <p:spPr>
+          <a:xfrm>
+            <a:off x="0" y="0"/>
+            <a:ext cx="164592" cy="6858000"/>
+          </a:xfrm>
+          <a:prstGeom prst="rect">
+            <a:avLst/>
+          </a:prstGeom>
+          <a:solidFill>
+            <a:srgbClr val="97BC62"/>
+          </a:solidFill>
+          <a:ln w="12700">
+            <a:solidFill>
+              <a:srgbClr val="97BC62"/>
+            </a:solidFill>
+            <a:prstDash val="solid"/>
+          </a:ln>
+        </p:spPr>
+        <p:txBody>
+          <a:bodyPr/>
+          <a:lstStyle/>
+          <a:p>
+            <a:endParaRPr/>
+          </a:p>
+        </p:txBody>
+      </p:sp>
+      <p:sp>
+        <p:nvSpPr>
+          <p:cNvPr id="3" name="Shape 1"/>
+          <p:cNvSpPr/>
+          <p:nvPr/>
+        </p:nvSpPr>
+        <p:spPr>
+          <a:xfrm>
+            <a:off x="11521440" y="0"/>
+            <a:ext cx="640080" cy="164592"/>
+          </a:xfrm>
+          <a:prstGeom prst="rect">
+            <a:avLst/>
+          </a:prstGeom>
+          <a:solidFill>
+            <a:srgbClr val="97BC62"/>
+          </a:solidFill>
+          <a:ln w="12700">
+            <a:solidFill>
+              <a:srgbClr val="97BC62"/>
+            </a:solidFill>
+            <a:prstDash val="solid"/>
+          </a:ln>
+        </p:spPr>
+        <p:txBody>
+          <a:bodyPr/>
+          <a:lstStyle/>
+          <a:p>
+            <a:endParaRPr/>
+          </a:p>
+        </p:txBody>
+      </p:sp>
+      <p:sp>
+        <p:nvSpPr>
+          <p:cNvPr id="4" name="Text 2"/>
+          <p:cNvSpPr/>
+          <p:nvPr/>
+        </p:nvSpPr>
+        <p:spPr>
+          <a:xfrm>
+            <a:off x="731520" y="2286000"/>
+            <a:ext cx="10972800" cy="1371600"/>
+          </a:xfrm>
+          <a:prstGeom prst="rect">
+            <a:avLst/>
+          </a:prstGeom>
+          <a:noFill/>
+          <a:ln/>
+        </p:spPr>
+        <p:txBody>
+          <a:bodyPr wrap="square" rtlCol="0" anchor="ctr"/>
+          <a:lstStyle/>
+          <a:p>
+            <a:pPr marL="0" indent="0">
+              <a:buNone/>
+            </a:pPr>
+            <a:r>
+              <a:rPr lang="en-US" sz="7200" b="1" dirty="0">
+                <a:solidFill>
+                  <a:srgbClr val="FFFFFF"/>
+                </a:solidFill>
+                <a:latin typeface="Helvetica" pitchFamily="34" charset="0"/>
+                <a:ea typeface="Helvetica" pitchFamily="34" charset="-122"/>
+                <a:cs typeface="Helvetica" pitchFamily="34" charset="-120"/>
+              </a:rPr>
+              <a:t>Cảm ơn!</a:t>
+            </a:r>
+            <a:endParaRPr lang="en-US" sz="7200" dirty="0"/>
+          </a:p>
+        </p:txBody>
+      </p:sp>
+      <p:sp>
+        <p:nvSpPr>
+          <p:cNvPr id="5" name="Text 3"/>
+          <p:cNvSpPr/>
+          <p:nvPr/>
+        </p:nvSpPr>
+        <p:spPr>
+          <a:xfrm>
+            <a:off x="731520" y="3657600"/>
+            <a:ext cx="10972800" cy="731520"/>
+          </a:xfrm>
+          <a:prstGeom prst="rect">
+            <a:avLst/>
+          </a:prstGeom>
+          <a:noFill/>
+          <a:ln/>
+        </p:spPr>
+        <p:txBody>
+          <a:bodyPr wrap="square" rtlCol="0" anchor="ctr"/>
+          <a:lstStyle/>
+          <a:p>
+            <a:pPr marL="0" indent="0">
+              <a:buNone/>
+            </a:pPr>
+            <a:r>
+              <a:rPr lang="en-US" sz="2400" dirty="0">
+                <a:solidFill>
+                  <a:srgbClr val="97BC62"/>
+                </a:solidFill>
+                <a:latin typeface="Helvetica" pitchFamily="34" charset="0"/>
+                <a:ea typeface="Helvetica" pitchFamily="34" charset="-122"/>
+                <a:cs typeface="Helvetica" pitchFamily="34" charset="-120"/>
+              </a:rPr>
+              <a:t>Hẹn gặp lại ở ca 2 — góc nhìn Product &amp; Indie</a:t>
+            </a:r>
+            <a:endParaRPr lang="en-US" sz="2400" dirty="0"/>
+          </a:p>
+        </p:txBody>
+      </p:sp>
+      <p:sp>
+        <p:nvSpPr>
+          <p:cNvPr id="6" name="Text 4"/>
+          <p:cNvSpPr/>
+          <p:nvPr/>
+        </p:nvSpPr>
+        <p:spPr>
+          <a:xfrm>
+            <a:off x="731520" y="5029200"/>
+            <a:ext cx="10972800" cy="548640"/>
+          </a:xfrm>
+          <a:prstGeom prst="rect">
+            <a:avLst/>
+          </a:prstGeom>
+          <a:noFill/>
+          <a:ln/>
+        </p:spPr>
+        <p:txBody>
+          <a:bodyPr wrap="square" rtlCol="0" anchor="ctr"/>
+          <a:lstStyle/>
+          <a:p>
+            <a:pPr marL="0" indent="0">
+              <a:buNone/>
+            </a:pPr>
+            <a:r>
+              <a:rPr lang="en-US" sz="2000" b="1" dirty="0">
+                <a:solidFill>
+                  <a:srgbClr val="FFFFFF"/>
+                </a:solidFill>
+                <a:latin typeface="Helvetica" pitchFamily="34" charset="0"/>
+                <a:ea typeface="Helvetica" pitchFamily="34" charset="-122"/>
+                <a:cs typeface="Helvetica" pitchFamily="34" charset="-120"/>
+              </a:rPr>
+              <a:t>Nguyễn Quế Lân · VNGalaxy</a:t>
+            </a:r>
+            <a:endParaRPr lang="en-US" sz="2000" dirty="0"/>
+          </a:p>
+        </p:txBody>
+      </p:sp>
+      <p:sp>
+        <p:nvSpPr>
+          <p:cNvPr id="7" name="Text 5"/>
+          <p:cNvSpPr/>
+          <p:nvPr/>
+        </p:nvSpPr>
+        <p:spPr>
+          <a:xfrm>
+            <a:off x="7772400" y="6492240"/>
+            <a:ext cx="4114800" cy="274320"/>
+          </a:xfrm>
+          <a:prstGeom prst="rect">
+            <a:avLst/>
+          </a:prstGeom>
+          <a:noFill/>
+          <a:ln/>
+        </p:spPr>
+        <p:txBody>
+          <a:bodyPr wrap="square" rtlCol="0" anchor="ctr"/>
+          <a:lstStyle/>
+          <a:p>
+            <a:pPr marL="0" indent="0" algn="r">
+              <a:buNone/>
+            </a:pPr>
+            <a:r>
+              <a:rPr lang="en-US" sz="1100" dirty="0">
+                <a:solidFill>
+                  <a:srgbClr val="97BC62"/>
                 </a:solidFill>
                 <a:latin typeface="Helvetica" pitchFamily="34" charset="0"/>
                 <a:ea typeface="Helvetica" pitchFamily="34" charset="-122"/>
@@ -20403,6 +21398,256 @@
 
 <file path=ppt/slides/slide7.xml><?xml version="1.0" encoding="utf-8"?>
 <p:sld xmlns:a="http://schemas.openxmlformats.org/drawingml/2006/main" xmlns:r="http://schemas.openxmlformats.org/officeDocument/2006/relationships" xmlns:p="http://schemas.openxmlformats.org/presentationml/2006/main">
+  <p:cSld>
+    <p:spTree>
+      <p:nvGrpSpPr>
+        <p:cNvPr id="1" name="">
+          <a:extLst>
+            <a:ext uri="{FF2B5EF4-FFF2-40B4-BE49-F238E27FC236}">
+              <a16:creationId xmlns:a16="http://schemas.microsoft.com/office/drawing/2014/main" id="{5F94C9CF-1674-A7A5-925B-FDF20432E4AE}"/>
+            </a:ext>
+          </a:extLst>
+        </p:cNvPr>
+        <p:cNvGrpSpPr/>
+        <p:nvPr/>
+      </p:nvGrpSpPr>
+      <p:grpSpPr>
+        <a:xfrm>
+          <a:off x="0" y="0"/>
+          <a:ext cx="0" cy="0"/>
+          <a:chOff x="0" y="0"/>
+          <a:chExt cx="0" cy="0"/>
+        </a:xfrm>
+      </p:grpSpPr>
+      <p:sp>
+        <p:nvSpPr>
+          <p:cNvPr id="2" name="Shape 0">
+            <a:extLst>
+              <a:ext uri="{FF2B5EF4-FFF2-40B4-BE49-F238E27FC236}">
+                <a16:creationId xmlns:a16="http://schemas.microsoft.com/office/drawing/2014/main" id="{8B299D20-2689-7ED1-FE41-73D7997714A9}"/>
+              </a:ext>
+            </a:extLst>
+          </p:cNvPr>
+          <p:cNvSpPr/>
+          <p:nvPr/>
+        </p:nvSpPr>
+        <p:spPr>
+          <a:xfrm>
+            <a:off x="0" y="0"/>
+            <a:ext cx="164592" cy="6858000"/>
+          </a:xfrm>
+          <a:prstGeom prst="rect">
+            <a:avLst/>
+          </a:prstGeom>
+          <a:solidFill>
+            <a:srgbClr val="97BC62"/>
+          </a:solidFill>
+          <a:ln w="12700">
+            <a:solidFill>
+              <a:srgbClr val="97BC62"/>
+            </a:solidFill>
+            <a:prstDash val="solid"/>
+          </a:ln>
+        </p:spPr>
+      </p:sp>
+      <p:sp>
+        <p:nvSpPr>
+          <p:cNvPr id="3" name="Shape 1">
+            <a:extLst>
+              <a:ext uri="{FF2B5EF4-FFF2-40B4-BE49-F238E27FC236}">
+                <a16:creationId xmlns:a16="http://schemas.microsoft.com/office/drawing/2014/main" id="{B0661B92-35AE-1753-877A-CBD4267C0F64}"/>
+              </a:ext>
+            </a:extLst>
+          </p:cNvPr>
+          <p:cNvSpPr/>
+          <p:nvPr/>
+        </p:nvSpPr>
+        <p:spPr>
+          <a:xfrm>
+            <a:off x="11521440" y="0"/>
+            <a:ext cx="640080" cy="164592"/>
+          </a:xfrm>
+          <a:prstGeom prst="rect">
+            <a:avLst/>
+          </a:prstGeom>
+          <a:solidFill>
+            <a:srgbClr val="97BC62"/>
+          </a:solidFill>
+          <a:ln w="12700">
+            <a:solidFill>
+              <a:srgbClr val="97BC62"/>
+            </a:solidFill>
+            <a:prstDash val="solid"/>
+          </a:ln>
+        </p:spPr>
+      </p:sp>
+      <p:sp>
+        <p:nvSpPr>
+          <p:cNvPr id="4" name="Text 2">
+            <a:extLst>
+              <a:ext uri="{FF2B5EF4-FFF2-40B4-BE49-F238E27FC236}">
+                <a16:creationId xmlns:a16="http://schemas.microsoft.com/office/drawing/2014/main" id="{C2E4058F-39E9-A179-EBA2-8C7BAA162FF2}"/>
+              </a:ext>
+            </a:extLst>
+          </p:cNvPr>
+          <p:cNvSpPr/>
+          <p:nvPr/>
+        </p:nvSpPr>
+        <p:spPr>
+          <a:xfrm>
+            <a:off x="731520" y="2377440"/>
+            <a:ext cx="10972800" cy="457200"/>
+          </a:xfrm>
+          <a:prstGeom prst="rect">
+            <a:avLst/>
+          </a:prstGeom>
+          <a:noFill/>
+          <a:ln/>
+        </p:spPr>
+        <p:txBody>
+          <a:bodyPr wrap="square" rtlCol="0" anchor="ctr"/>
+          <a:lstStyle/>
+          <a:p>
+            <a:pPr marL="0" indent="0">
+              <a:buNone/>
+            </a:pPr>
+            <a:r>
+              <a:rPr lang="en-US" sz="1800" b="1" kern="0" spc="400" dirty="0">
+                <a:solidFill>
+                  <a:srgbClr val="97BC62"/>
+                </a:solidFill>
+                <a:latin typeface="Helvetica" pitchFamily="34" charset="0"/>
+                <a:ea typeface="Helvetica" pitchFamily="34" charset="-122"/>
+                <a:cs typeface="Helvetica" pitchFamily="34" charset="-120"/>
+              </a:rPr>
+              <a:t>PHẦN 1 — KỸ THUẬT</a:t>
+            </a:r>
+            <a:endParaRPr lang="en-US" sz="1800" dirty="0"/>
+          </a:p>
+        </p:txBody>
+      </p:sp>
+      <p:sp>
+        <p:nvSpPr>
+          <p:cNvPr id="5" name="Text 3">
+            <a:extLst>
+              <a:ext uri="{FF2B5EF4-FFF2-40B4-BE49-F238E27FC236}">
+                <a16:creationId xmlns:a16="http://schemas.microsoft.com/office/drawing/2014/main" id="{2292144F-165D-1D73-051C-4B099850B6BB}"/>
+              </a:ext>
+            </a:extLst>
+          </p:cNvPr>
+          <p:cNvSpPr/>
+          <p:nvPr/>
+        </p:nvSpPr>
+        <p:spPr>
+          <a:xfrm>
+            <a:off x="731520" y="2834640"/>
+            <a:ext cx="10972800" cy="1828800"/>
+          </a:xfrm>
+          <a:prstGeom prst="rect">
+            <a:avLst/>
+          </a:prstGeom>
+          <a:noFill/>
+          <a:ln/>
+        </p:spPr>
+        <p:txBody>
+          <a:bodyPr wrap="square" rtlCol="0" anchor="ctr"/>
+          <a:lstStyle/>
+          <a:p>
+            <a:pPr marL="0" indent="0">
+              <a:buNone/>
+            </a:pPr>
+            <a:r>
+              <a:rPr lang="en-US" sz="5200" b="1" dirty="0">
+                <a:solidFill>
+                  <a:srgbClr val="FFFFFF"/>
+                </a:solidFill>
+                <a:latin typeface="Helvetica" pitchFamily="34" charset="0"/>
+                <a:ea typeface="Helvetica" pitchFamily="34" charset="-122"/>
+                <a:cs typeface="Helvetica" pitchFamily="34" charset="-120"/>
+              </a:rPr>
+              <a:t>Lập trình iOS</a:t>
+            </a:r>
+            <a:endParaRPr lang="en-US" sz="5200" dirty="0"/>
+          </a:p>
+          <a:p>
+            <a:pPr marL="0" indent="0">
+              <a:buNone/>
+            </a:pPr>
+            <a:r>
+              <a:rPr lang="en-US" sz="5200" b="1" dirty="0">
+                <a:solidFill>
+                  <a:srgbClr val="FFFFFF"/>
+                </a:solidFill>
+                <a:latin typeface="Helvetica" pitchFamily="34" charset="0"/>
+                <a:ea typeface="Helvetica" pitchFamily="34" charset="-122"/>
+                <a:cs typeface="Helvetica" pitchFamily="34" charset="-120"/>
+              </a:rPr>
+              <a:t>hôm nay trông như thế nào?</a:t>
+            </a:r>
+            <a:endParaRPr lang="en-US" sz="5200" dirty="0"/>
+          </a:p>
+        </p:txBody>
+      </p:sp>
+      <p:sp>
+        <p:nvSpPr>
+          <p:cNvPr id="6" name="Text 4">
+            <a:extLst>
+              <a:ext uri="{FF2B5EF4-FFF2-40B4-BE49-F238E27FC236}">
+                <a16:creationId xmlns:a16="http://schemas.microsoft.com/office/drawing/2014/main" id="{9E37687A-73AB-6C12-F77C-9D87E7AB263F}"/>
+              </a:ext>
+            </a:extLst>
+          </p:cNvPr>
+          <p:cNvSpPr/>
+          <p:nvPr/>
+        </p:nvSpPr>
+        <p:spPr>
+          <a:xfrm>
+            <a:off x="7772400" y="6492240"/>
+            <a:ext cx="4114800" cy="274320"/>
+          </a:xfrm>
+          <a:prstGeom prst="rect">
+            <a:avLst/>
+          </a:prstGeom>
+          <a:noFill/>
+          <a:ln/>
+        </p:spPr>
+        <p:txBody>
+          <a:bodyPr wrap="square" rtlCol="0" anchor="ctr"/>
+          <a:lstStyle/>
+          <a:p>
+            <a:pPr marL="0" indent="0" algn="r">
+              <a:buNone/>
+            </a:pPr>
+            <a:r>
+              <a:rPr lang="en-US" sz="1100" dirty="0">
+                <a:solidFill>
+                  <a:srgbClr val="97BC62"/>
+                </a:solidFill>
+                <a:latin typeface="Helvetica" pitchFamily="34" charset="0"/>
+                <a:ea typeface="Helvetica" pitchFamily="34" charset="-122"/>
+                <a:cs typeface="Helvetica" pitchFamily="34" charset="-120"/>
+              </a:rPr>
+              <a:t>Nguyễn Quế Lân · VNGalaxy</a:t>
+            </a:r>
+            <a:endParaRPr lang="en-US" sz="1100" dirty="0"/>
+          </a:p>
+        </p:txBody>
+      </p:sp>
+    </p:spTree>
+    <p:extLst>
+      <p:ext uri="{BB962C8B-B14F-4D97-AF65-F5344CB8AC3E}">
+        <p14:creationId xmlns:p14="http://schemas.microsoft.com/office/powerpoint/2010/main" val="3673735528"/>
+      </p:ext>
+    </p:extLst>
+  </p:cSld>
+  <p:clrMapOvr>
+    <a:masterClrMapping/>
+  </p:clrMapOvr>
+</p:sld>
+</file>
+
+<file path=ppt/slides/slide8.xml><?xml version="1.0" encoding="utf-8"?>
+<p:sld xmlns:a="http://schemas.openxmlformats.org/drawingml/2006/main" xmlns:r="http://schemas.openxmlformats.org/officeDocument/2006/relationships" xmlns:p="http://schemas.openxmlformats.org/presentationml/2006/main">
   <p:cSld name="Slide 7">
     <p:bg>
       <p:bgPr>
@@ -21598,7 +22843,7 @@
 </p:sld>
 </file>
 
-<file path=ppt/slides/slide8.xml><?xml version="1.0" encoding="utf-8"?>
+<file path=ppt/slides/slide9.xml><?xml version="1.0" encoding="utf-8"?>
 <p:sld xmlns:a="http://schemas.openxmlformats.org/drawingml/2006/main" xmlns:r="http://schemas.openxmlformats.org/officeDocument/2006/relationships" xmlns:p="http://schemas.openxmlformats.org/presentationml/2006/main">
   <p:cSld name="Slide 8">
     <p:bg>
@@ -22904,223 +24149,6 @@
               <a:rPr lang="en-US" sz="1100" dirty="0">
                 <a:solidFill>
                   <a:srgbClr val="555555"/>
-                </a:solidFill>
-                <a:latin typeface="Helvetica" pitchFamily="34" charset="0"/>
-                <a:ea typeface="Helvetica" pitchFamily="34" charset="-122"/>
-                <a:cs typeface="Helvetica" pitchFamily="34" charset="-120"/>
-              </a:rPr>
-              <a:t>Nguyễn Quế Lân · VNGalaxy</a:t>
-            </a:r>
-            <a:endParaRPr lang="en-US" sz="1100" dirty="0"/>
-          </a:p>
-        </p:txBody>
-      </p:sp>
-    </p:spTree>
-  </p:cSld>
-  <p:clrMapOvr>
-    <a:masterClrMapping/>
-  </p:clrMapOvr>
-</p:sld>
-</file>
-
-<file path=ppt/slides/slide9.xml><?xml version="1.0" encoding="utf-8"?>
-<p:sld xmlns:a="http://schemas.openxmlformats.org/drawingml/2006/main" xmlns:r="http://schemas.openxmlformats.org/officeDocument/2006/relationships" xmlns:p="http://schemas.openxmlformats.org/presentationml/2006/main">
-  <p:cSld name="Slide 9">
-    <p:bg>
-      <p:bgPr>
-        <a:solidFill>
-          <a:srgbClr val="1B3A1F"/>
-        </a:solidFill>
-        <a:effectLst/>
-      </p:bgPr>
-    </p:bg>
-    <p:spTree>
-      <p:nvGrpSpPr>
-        <p:cNvPr id="1" name=""/>
-        <p:cNvGrpSpPr/>
-        <p:nvPr/>
-      </p:nvGrpSpPr>
-      <p:grpSpPr>
-        <a:xfrm>
-          <a:off x="0" y="0"/>
-          <a:ext cx="0" cy="0"/>
-          <a:chOff x="0" y="0"/>
-          <a:chExt cx="0" cy="0"/>
-        </a:xfrm>
-      </p:grpSpPr>
-      <p:sp>
-        <p:nvSpPr>
-          <p:cNvPr id="2" name="Shape 0"/>
-          <p:cNvSpPr/>
-          <p:nvPr/>
-        </p:nvSpPr>
-        <p:spPr>
-          <a:xfrm>
-            <a:off x="0" y="0"/>
-            <a:ext cx="164592" cy="6858000"/>
-          </a:xfrm>
-          <a:prstGeom prst="rect">
-            <a:avLst/>
-          </a:prstGeom>
-          <a:solidFill>
-            <a:srgbClr val="97BC62"/>
-          </a:solidFill>
-          <a:ln w="12700">
-            <a:solidFill>
-              <a:srgbClr val="97BC62"/>
-            </a:solidFill>
-            <a:prstDash val="solid"/>
-          </a:ln>
-        </p:spPr>
-      </p:sp>
-      <p:sp>
-        <p:nvSpPr>
-          <p:cNvPr id="3" name="Shape 1"/>
-          <p:cNvSpPr/>
-          <p:nvPr/>
-        </p:nvSpPr>
-        <p:spPr>
-          <a:xfrm>
-            <a:off x="11521440" y="0"/>
-            <a:ext cx="640080" cy="164592"/>
-          </a:xfrm>
-          <a:prstGeom prst="rect">
-            <a:avLst/>
-          </a:prstGeom>
-          <a:solidFill>
-            <a:srgbClr val="97BC62"/>
-          </a:solidFill>
-          <a:ln w="12700">
-            <a:solidFill>
-              <a:srgbClr val="97BC62"/>
-            </a:solidFill>
-            <a:prstDash val="solid"/>
-          </a:ln>
-        </p:spPr>
-      </p:sp>
-      <p:sp>
-        <p:nvSpPr>
-          <p:cNvPr id="4" name="Text 2"/>
-          <p:cNvSpPr/>
-          <p:nvPr/>
-        </p:nvSpPr>
-        <p:spPr>
-          <a:xfrm>
-            <a:off x="731520" y="2377440"/>
-            <a:ext cx="10972800" cy="457200"/>
-          </a:xfrm>
-          <a:prstGeom prst="rect">
-            <a:avLst/>
-          </a:prstGeom>
-          <a:noFill/>
-          <a:ln/>
-        </p:spPr>
-        <p:txBody>
-          <a:bodyPr wrap="square" rtlCol="0" anchor="ctr"/>
-          <a:lstStyle/>
-          <a:p>
-            <a:pPr marL="0" indent="0">
-              <a:buNone/>
-            </a:pPr>
-            <a:r>
-              <a:rPr lang="en-US" sz="1800" b="1" kern="0" spc="400" dirty="0">
-                <a:solidFill>
-                  <a:srgbClr val="97BC62"/>
-                </a:solidFill>
-                <a:latin typeface="Helvetica" pitchFamily="34" charset="0"/>
-                <a:ea typeface="Helvetica" pitchFamily="34" charset="-122"/>
-                <a:cs typeface="Helvetica" pitchFamily="34" charset="-120"/>
-              </a:rPr>
-              <a:t>LỊCH SỬ NGÔN NGỮ</a:t>
-            </a:r>
-            <a:endParaRPr lang="en-US" sz="1800" dirty="0"/>
-          </a:p>
-        </p:txBody>
-      </p:sp>
-      <p:sp>
-        <p:nvSpPr>
-          <p:cNvPr id="5" name="Text 3"/>
-          <p:cNvSpPr/>
-          <p:nvPr/>
-        </p:nvSpPr>
-        <p:spPr>
-          <a:xfrm>
-            <a:off x="731520" y="2834640"/>
-            <a:ext cx="10972800" cy="1828800"/>
-          </a:xfrm>
-          <a:prstGeom prst="rect">
-            <a:avLst/>
-          </a:prstGeom>
-          <a:noFill/>
-          <a:ln/>
-        </p:spPr>
-        <p:txBody>
-          <a:bodyPr wrap="square" rtlCol="0" anchor="ctr"/>
-          <a:lstStyle/>
-          <a:p>
-            <a:pPr marL="0" indent="0">
-              <a:buNone/>
-            </a:pPr>
-            <a:r>
-              <a:rPr lang="en-US" sz="5200" b="1" dirty="0">
-                <a:solidFill>
-                  <a:srgbClr val="FFFFFF"/>
-                </a:solidFill>
-                <a:latin typeface="Helvetica" pitchFamily="34" charset="0"/>
-                <a:ea typeface="Helvetica" pitchFamily="34" charset="-122"/>
-                <a:cs typeface="Helvetica" pitchFamily="34" charset="-120"/>
-              </a:rPr>
-              <a:t>Từ Objective-C</a:t>
-            </a:r>
-            <a:endParaRPr lang="en-US" sz="5200" dirty="0"/>
-          </a:p>
-          <a:p>
-            <a:pPr marL="0" indent="0">
-              <a:buNone/>
-            </a:pPr>
-            <a:r>
-              <a:rPr lang="en-US" sz="5200" b="1" dirty="0">
-                <a:solidFill>
-                  <a:srgbClr val="FFFFFF"/>
-                </a:solidFill>
-                <a:latin typeface="Helvetica" pitchFamily="34" charset="0"/>
-                <a:ea typeface="Helvetica" pitchFamily="34" charset="-122"/>
-                <a:cs typeface="Helvetica" pitchFamily="34" charset="-120"/>
-              </a:rPr>
-              <a:t>đến Swift</a:t>
-            </a:r>
-            <a:endParaRPr lang="en-US" sz="5200" dirty="0"/>
-          </a:p>
-        </p:txBody>
-      </p:sp>
-      <p:sp>
-        <p:nvSpPr>
-          <p:cNvPr id="6" name="Text 4"/>
-          <p:cNvSpPr/>
-          <p:nvPr/>
-        </p:nvSpPr>
-        <p:spPr>
-          <a:xfrm>
-            <a:off x="7772400" y="6492240"/>
-            <a:ext cx="4114800" cy="274320"/>
-          </a:xfrm>
-          <a:prstGeom prst="rect">
-            <a:avLst/>
-          </a:prstGeom>
-          <a:noFill/>
-          <a:ln/>
-        </p:spPr>
-        <p:txBody>
-          <a:bodyPr wrap="square" rtlCol="0" anchor="ctr"/>
-          <a:lstStyle/>
-          <a:p>
-            <a:pPr marL="0" indent="0" algn="r">
-              <a:buNone/>
-            </a:pPr>
-            <a:r>
-              <a:rPr lang="en-US" sz="1100" dirty="0">
-                <a:solidFill>
-                  <a:srgbClr val="97BC62"/>
                 </a:solidFill>
                 <a:latin typeface="Helvetica" pitchFamily="34" charset="0"/>
                 <a:ea typeface="Helvetica" pitchFamily="34" charset="-122"/>

</xml_diff>